<commit_message>
Show ground sales as main channel; add door-to-door and booth
Co-Authored-By: Claude Opus 5.5 <noreply@anthropic.com>
Claude-Session: https://claude.ai/code/session_019TrPFwnRk1PSQav8m5MwcQ
</commit_message>
<xml_diff>
--- a/HFS_Strategi_Jualan_Unifi_Q4_2026_v2.pptx
+++ b/HFS_Strategi_Jualan_Unifi_Q4_2026_v2.pptx
@@ -2717,7 +2717,7 @@
           <a:p>
             <a:r>
               <a:rPr lang="en-US" dirty="0"/>
-              <a:t>Jualan kita datang dari dua saluran. Pertama, ground sales: poster di kawasan perumahan, referral customer dan poster blitz hujung minggu. Kedua, digital: TikTok, Facebook dan yang terkini, Threads. TikTok masih bawa jualan, Facebook dah menurun, dan Threads ialah platform terbaru kita. Mulai minggu ni, setiap lead kita rekod ikut saluran supaya kita tahu mana yang paling berkesan.</a:t>
+              <a:t>Jualan kita datang dari dua saluran. Kebanyakan jualan datang dari ground sales: door-to-door, booth, poster termasuk poster blitz, serta referral customer. Selebihnya datang dari digital: TikTok, Facebook dan yang terkini, Threads. Dalam digital, TikTok masih bawa jualan, Facebook dah menurun, dan Threads ialah platform terbaru kita. Mulai minggu ni, setiap lead kita rekod ikut saluran supaya kita tahu mana yang paling berkesan.</a:t>
             </a:r>
             <a:endParaRPr lang="en-US" dirty="0"/>
           </a:p>
@@ -18665,7 +18665,7 @@
                           <a:ea typeface="Calibri" pitchFamily="34" charset="-122"/>
                           <a:cs typeface="Calibri" pitchFamily="34" charset="-120"/>
                         </a:rPr>
-                        <a:t>Ground: Poster (lokasi), Referral  ·  Digital: TikTok (nama video), Facebook, Threads</a:t>
+                        <a:t>Ground: Door-to-door, Booth (lokasi), Poster (lokasi), Referral  ·  Digital: TikTok (nama video), Facebook, Threads</a:t>
                       </a:r>
                       <a:endParaRPr lang="en-US" sz="1400" dirty="0">
                         <a:latin typeface="Calibri" charset="0"/>
@@ -25720,7 +25720,7 @@
                 <a:ea typeface="Calibri" pitchFamily="34" charset="-122"/>
                 <a:cs typeface="Calibri" pitchFamily="34" charset="-120"/>
               </a:rPr>
-              <a:t>Jualan kita datang dari dua saluran: ground sales dan digital</a:t>
+              <a:t>Kebanyakan jualan datang dari ground sales, selebihnya dari digital</a:t>
             </a:r>
             <a:endParaRPr lang="en-US" sz="2800" dirty="0"/>
           </a:p>
@@ -25893,7 +25893,860 @@
         <p:spPr>
           <a:xfrm>
             <a:off x="548640" y="1600200"/>
-            <a:ext cx="4572000" cy="3749040"/>
+            <a:ext cx="6583680" cy="3749040"/>
+          </a:xfrm>
+          <a:prstGeom prst="roundRect">
+            <a:avLst>
+              <a:gd name="adj" fmla="val 1951"/>
+            </a:avLst>
+          </a:prstGeom>
+          <a:solidFill>
+            <a:srgbClr val="0B1F3A"/>
+          </a:solidFill>
+          <a:ln w="12700">
+            <a:solidFill>
+              <a:srgbClr val="0B1F3A"/>
+            </a:solidFill>
+            <a:prstDash val="solid"/>
+          </a:ln>
+          <a:effectLst>
+            <a:outerShdw sx="100000" sy="100000" kx="0" ky="0" algn="bl" rotWithShape="0" blurRad="127000" dist="25400" dir="5400000">
+              <a:srgbClr val="0B1F3A">
+                <a:alpha val="10000"/>
+              </a:srgbClr>
+            </a:outerShdw>
+          </a:effectLst>
+        </p:spPr>
+      </p:sp>
+      <p:sp>
+        <p:nvSpPr>
+          <p:cNvPr id="9" name="Shape 7"/>
+          <p:cNvSpPr/>
+          <p:nvPr/>
+        </p:nvSpPr>
+        <p:spPr>
+          <a:xfrm>
+            <a:off x="868680" y="1920240"/>
+            <a:ext cx="640080" cy="640080"/>
+          </a:xfrm>
+          <a:prstGeom prst="roundRect">
+            <a:avLst>
+              <a:gd name="adj" fmla="val 22000"/>
+            </a:avLst>
+          </a:prstGeom>
+          <a:solidFill>
+            <a:srgbClr val="C8742B"/>
+          </a:solidFill>
+          <a:ln w="12700">
+            <a:solidFill>
+              <a:srgbClr val="C8742B"/>
+            </a:solidFill>
+            <a:prstDash val="solid"/>
+          </a:ln>
+        </p:spPr>
+      </p:sp>
+      <p:pic>
+        <p:nvPicPr>
+          <p:cNvPr id="10" name="Image 0" descr="preencoded.png">    </p:cNvPr>
+          <p:cNvPicPr>
+            <a:picLocks noChangeAspect="1"/>
+          </p:cNvPicPr>
+          <p:nvPr/>
+        </p:nvPicPr>
+        <p:blipFill>
+          <a:blip r:embed="rId1"/>
+          <a:stretch>
+            <a:fillRect/>
+          </a:stretch>
+        </p:blipFill>
+        <p:spPr>
+          <a:xfrm>
+            <a:off x="1022299" y="2073859"/>
+            <a:ext cx="332842" cy="332842"/>
+          </a:xfrm>
+          <a:prstGeom prst="rect">
+            <a:avLst/>
+          </a:prstGeom>
+        </p:spPr>
+      </p:pic>
+      <p:sp>
+        <p:nvSpPr>
+          <p:cNvPr id="11" name="Text 8"/>
+          <p:cNvSpPr txBox="1"/>
+          <p:nvPr/>
+        </p:nvSpPr>
+        <p:spPr>
+          <a:xfrm>
+            <a:off x="1691640" y="1920240"/>
+            <a:ext cx="3657600" cy="256032"/>
+          </a:xfrm>
+          <a:prstGeom prst="rect">
+            <a:avLst/>
+          </a:prstGeom>
+          <a:noFill/>
+          <a:ln/>
+        </p:spPr>
+        <p:txBody>
+          <a:bodyPr wrap="square" lIns="0" tIns="0" rIns="0" bIns="0" rtlCol="0" anchor="t"/>
+          <a:lstStyle/>
+          <a:p>
+            <a:pPr indent="0" marL="0">
+              <a:buNone/>
+            </a:pPr>
+            <a:r>
+              <a:rPr lang="en-US" sz="1100" b="1" spc="200" kern="0" dirty="0">
+                <a:solidFill>
+                  <a:srgbClr val="C8742B"/>
+                </a:solidFill>
+                <a:latin typeface="Calibri" pitchFamily="34" charset="0"/>
+                <a:ea typeface="Calibri" pitchFamily="34" charset="-122"/>
+                <a:cs typeface="Calibri" pitchFamily="34" charset="-120"/>
+              </a:rPr>
+              <a:t>SALURAN 01  ·  SUMBER UTAMA</a:t>
+            </a:r>
+            <a:endParaRPr lang="en-US" sz="1100" dirty="0"/>
+          </a:p>
+        </p:txBody>
+      </p:sp>
+      <p:sp>
+        <p:nvSpPr>
+          <p:cNvPr id="12" name="Text 9"/>
+          <p:cNvSpPr txBox="1"/>
+          <p:nvPr/>
+        </p:nvSpPr>
+        <p:spPr>
+          <a:xfrm>
+            <a:off x="1691640" y="2167128"/>
+            <a:ext cx="3200400" cy="411480"/>
+          </a:xfrm>
+          <a:prstGeom prst="rect">
+            <a:avLst/>
+          </a:prstGeom>
+          <a:noFill/>
+          <a:ln/>
+        </p:spPr>
+        <p:txBody>
+          <a:bodyPr wrap="square" lIns="0" tIns="0" rIns="0" bIns="0" rtlCol="0" anchor="ctr"/>
+          <a:lstStyle/>
+          <a:p>
+            <a:pPr indent="0" marL="0">
+              <a:buNone/>
+            </a:pPr>
+            <a:r>
+              <a:rPr lang="en-US" sz="2600" b="1" dirty="0">
+                <a:solidFill>
+                  <a:srgbClr val="FFFFFF"/>
+                </a:solidFill>
+                <a:latin typeface="Calibri" pitchFamily="34" charset="0"/>
+                <a:ea typeface="Calibri" pitchFamily="34" charset="-122"/>
+                <a:cs typeface="Calibri" pitchFamily="34" charset="-120"/>
+              </a:rPr>
+              <a:t>Ground sales</a:t>
+            </a:r>
+            <a:endParaRPr lang="en-US" sz="2600" dirty="0"/>
+          </a:p>
+        </p:txBody>
+      </p:sp>
+      <p:sp>
+        <p:nvSpPr>
+          <p:cNvPr id="13" name="Shape 10"/>
+          <p:cNvSpPr/>
+          <p:nvPr/>
+        </p:nvSpPr>
+        <p:spPr>
+          <a:xfrm>
+            <a:off x="5166360" y="2057400"/>
+            <a:ext cx="1645920" cy="365760"/>
+          </a:xfrm>
+          <a:prstGeom prst="roundRect">
+            <a:avLst>
+              <a:gd name="adj" fmla="val 50000"/>
+            </a:avLst>
+          </a:prstGeom>
+          <a:solidFill>
+            <a:srgbClr val="C8742B"/>
+          </a:solidFill>
+          <a:ln w="12700">
+            <a:solidFill>
+              <a:srgbClr val="C8742B"/>
+            </a:solidFill>
+            <a:prstDash val="solid"/>
+          </a:ln>
+        </p:spPr>
+      </p:sp>
+      <p:sp>
+        <p:nvSpPr>
+          <p:cNvPr id="14" name="Text 11"/>
+          <p:cNvSpPr txBox="1"/>
+          <p:nvPr/>
+        </p:nvSpPr>
+        <p:spPr>
+          <a:xfrm>
+            <a:off x="5166360" y="2057400"/>
+            <a:ext cx="1645920" cy="365760"/>
+          </a:xfrm>
+          <a:prstGeom prst="rect">
+            <a:avLst/>
+          </a:prstGeom>
+          <a:noFill/>
+          <a:ln/>
+        </p:spPr>
+        <p:txBody>
+          <a:bodyPr wrap="square" lIns="0" tIns="0" rIns="0" bIns="0" rtlCol="0" anchor="ctr"/>
+          <a:lstStyle/>
+          <a:p>
+            <a:pPr algn="ctr" indent="0" marL="0">
+              <a:buNone/>
+            </a:pPr>
+            <a:r>
+              <a:rPr lang="en-US" sz="1200" b="1" dirty="0">
+                <a:solidFill>
+                  <a:srgbClr val="FFFFFF"/>
+                </a:solidFill>
+                <a:latin typeface="Calibri" pitchFamily="34" charset="0"/>
+                <a:ea typeface="Calibri" pitchFamily="34" charset="-122"/>
+                <a:cs typeface="Calibri" pitchFamily="34" charset="-120"/>
+              </a:rPr>
+              <a:t>Majoriti jualan</a:t>
+            </a:r>
+            <a:endParaRPr lang="en-US" sz="1200" dirty="0"/>
+          </a:p>
+        </p:txBody>
+      </p:sp>
+      <p:sp>
+        <p:nvSpPr>
+          <p:cNvPr id="15" name="Shape 12"/>
+          <p:cNvSpPr/>
+          <p:nvPr/>
+        </p:nvSpPr>
+        <p:spPr>
+          <a:xfrm>
+            <a:off x="868680" y="2834640"/>
+            <a:ext cx="2857500" cy="1005840"/>
+          </a:xfrm>
+          <a:prstGeom prst="roundRect">
+            <a:avLst>
+              <a:gd name="adj" fmla="val 7273"/>
+            </a:avLst>
+          </a:prstGeom>
+          <a:solidFill>
+            <a:srgbClr val="17325A"/>
+          </a:solidFill>
+          <a:ln w="9525">
+            <a:solidFill>
+              <a:srgbClr val="23436F"/>
+            </a:solidFill>
+            <a:prstDash val="solid"/>
+          </a:ln>
+        </p:spPr>
+      </p:sp>
+      <p:sp>
+        <p:nvSpPr>
+          <p:cNvPr id="16" name="Shape 13"/>
+          <p:cNvSpPr/>
+          <p:nvPr/>
+        </p:nvSpPr>
+        <p:spPr>
+          <a:xfrm>
+            <a:off x="1069848" y="3081528"/>
+            <a:ext cx="512064" cy="512064"/>
+          </a:xfrm>
+          <a:prstGeom prst="roundRect">
+            <a:avLst>
+              <a:gd name="adj" fmla="val 22000"/>
+            </a:avLst>
+          </a:prstGeom>
+          <a:solidFill>
+            <a:srgbClr val="23436F"/>
+          </a:solidFill>
+          <a:ln w="12700">
+            <a:solidFill>
+              <a:srgbClr val="23436F"/>
+            </a:solidFill>
+            <a:prstDash val="solid"/>
+          </a:ln>
+        </p:spPr>
+      </p:sp>
+      <p:pic>
+        <p:nvPicPr>
+          <p:cNvPr id="17" name="Image 1" descr="preencoded.png">    </p:cNvPr>
+          <p:cNvPicPr>
+            <a:picLocks noChangeAspect="1"/>
+          </p:cNvPicPr>
+          <p:nvPr/>
+        </p:nvPicPr>
+        <p:blipFill>
+          <a:blip r:embed="rId2"/>
+          <a:stretch>
+            <a:fillRect/>
+          </a:stretch>
+        </p:blipFill>
+        <p:spPr>
+          <a:xfrm>
+            <a:off x="1192743" y="3204423"/>
+            <a:ext cx="266273" cy="266273"/>
+          </a:xfrm>
+          <a:prstGeom prst="rect">
+            <a:avLst/>
+          </a:prstGeom>
+        </p:spPr>
+      </p:pic>
+      <p:sp>
+        <p:nvSpPr>
+          <p:cNvPr id="18" name="Text 14"/>
+          <p:cNvSpPr txBox="1"/>
+          <p:nvPr/>
+        </p:nvSpPr>
+        <p:spPr>
+          <a:xfrm>
+            <a:off x="1737360" y="2999232"/>
+            <a:ext cx="1851660" cy="347472"/>
+          </a:xfrm>
+          <a:prstGeom prst="rect">
+            <a:avLst/>
+          </a:prstGeom>
+          <a:noFill/>
+          <a:ln/>
+        </p:spPr>
+        <p:txBody>
+          <a:bodyPr wrap="square" lIns="0" tIns="0" rIns="0" bIns="0" rtlCol="0" anchor="ctr"/>
+          <a:lstStyle/>
+          <a:p>
+            <a:pPr indent="0" marL="0">
+              <a:buNone/>
+            </a:pPr>
+            <a:r>
+              <a:rPr lang="en-US" sz="1600" b="1" dirty="0">
+                <a:solidFill>
+                  <a:srgbClr val="FFFFFF"/>
+                </a:solidFill>
+                <a:latin typeface="Calibri" pitchFamily="34" charset="0"/>
+                <a:ea typeface="Calibri" pitchFamily="34" charset="-122"/>
+                <a:cs typeface="Calibri" pitchFamily="34" charset="-120"/>
+              </a:rPr>
+              <a:t>Door-to-door</a:t>
+            </a:r>
+            <a:endParaRPr lang="en-US" sz="1600" dirty="0"/>
+          </a:p>
+        </p:txBody>
+      </p:sp>
+      <p:sp>
+        <p:nvSpPr>
+          <p:cNvPr id="19" name="Text 15"/>
+          <p:cNvSpPr txBox="1"/>
+          <p:nvPr/>
+        </p:nvSpPr>
+        <p:spPr>
+          <a:xfrm>
+            <a:off x="1737360" y="3346704"/>
+            <a:ext cx="1851660" cy="365760"/>
+          </a:xfrm>
+          <a:prstGeom prst="rect">
+            <a:avLst/>
+          </a:prstGeom>
+          <a:noFill/>
+          <a:ln/>
+        </p:spPr>
+        <p:txBody>
+          <a:bodyPr wrap="square" lIns="0" tIns="0" rIns="0" bIns="0" rtlCol="0" anchor="t"/>
+          <a:lstStyle/>
+          <a:p>
+            <a:pPr indent="0" marL="0">
+              <a:buNone/>
+            </a:pPr>
+            <a:r>
+              <a:rPr lang="en-US" sz="1200" dirty="0">
+                <a:solidFill>
+                  <a:srgbClr val="C3CEDD"/>
+                </a:solidFill>
+                <a:latin typeface="Calibri" pitchFamily="34" charset="0"/>
+                <a:ea typeface="Calibri" pitchFamily="34" charset="-122"/>
+                <a:cs typeface="Calibri" pitchFamily="34" charset="-120"/>
+              </a:rPr>
+              <a:t>Jumpa customer terus di rumah.</a:t>
+            </a:r>
+            <a:endParaRPr lang="en-US" sz="1200" dirty="0"/>
+          </a:p>
+        </p:txBody>
+      </p:sp>
+      <p:sp>
+        <p:nvSpPr>
+          <p:cNvPr id="20" name="Shape 16"/>
+          <p:cNvSpPr/>
+          <p:nvPr/>
+        </p:nvSpPr>
+        <p:spPr>
+          <a:xfrm>
+            <a:off x="3954780" y="2834640"/>
+            <a:ext cx="2857500" cy="1005840"/>
+          </a:xfrm>
+          <a:prstGeom prst="roundRect">
+            <a:avLst>
+              <a:gd name="adj" fmla="val 7273"/>
+            </a:avLst>
+          </a:prstGeom>
+          <a:solidFill>
+            <a:srgbClr val="17325A"/>
+          </a:solidFill>
+          <a:ln w="9525">
+            <a:solidFill>
+              <a:srgbClr val="23436F"/>
+            </a:solidFill>
+            <a:prstDash val="solid"/>
+          </a:ln>
+        </p:spPr>
+      </p:sp>
+      <p:sp>
+        <p:nvSpPr>
+          <p:cNvPr id="21" name="Shape 17"/>
+          <p:cNvSpPr/>
+          <p:nvPr/>
+        </p:nvSpPr>
+        <p:spPr>
+          <a:xfrm>
+            <a:off x="4155948" y="3081528"/>
+            <a:ext cx="512064" cy="512064"/>
+          </a:xfrm>
+          <a:prstGeom prst="roundRect">
+            <a:avLst>
+              <a:gd name="adj" fmla="val 22000"/>
+            </a:avLst>
+          </a:prstGeom>
+          <a:solidFill>
+            <a:srgbClr val="23436F"/>
+          </a:solidFill>
+          <a:ln w="12700">
+            <a:solidFill>
+              <a:srgbClr val="23436F"/>
+            </a:solidFill>
+            <a:prstDash val="solid"/>
+          </a:ln>
+        </p:spPr>
+      </p:sp>
+      <p:pic>
+        <p:nvPicPr>
+          <p:cNvPr id="22" name="Image 2" descr="preencoded.png">    </p:cNvPr>
+          <p:cNvPicPr>
+            <a:picLocks noChangeAspect="1"/>
+          </p:cNvPicPr>
+          <p:nvPr/>
+        </p:nvPicPr>
+        <p:blipFill>
+          <a:blip r:embed="rId3"/>
+          <a:stretch>
+            <a:fillRect/>
+          </a:stretch>
+        </p:blipFill>
+        <p:spPr>
+          <a:xfrm>
+            <a:off x="4278843" y="3204423"/>
+            <a:ext cx="266273" cy="266273"/>
+          </a:xfrm>
+          <a:prstGeom prst="rect">
+            <a:avLst/>
+          </a:prstGeom>
+        </p:spPr>
+      </p:pic>
+      <p:sp>
+        <p:nvSpPr>
+          <p:cNvPr id="23" name="Text 18"/>
+          <p:cNvSpPr txBox="1"/>
+          <p:nvPr/>
+        </p:nvSpPr>
+        <p:spPr>
+          <a:xfrm>
+            <a:off x="4823460" y="2999232"/>
+            <a:ext cx="1851660" cy="347472"/>
+          </a:xfrm>
+          <a:prstGeom prst="rect">
+            <a:avLst/>
+          </a:prstGeom>
+          <a:noFill/>
+          <a:ln/>
+        </p:spPr>
+        <p:txBody>
+          <a:bodyPr wrap="square" lIns="0" tIns="0" rIns="0" bIns="0" rtlCol="0" anchor="ctr"/>
+          <a:lstStyle/>
+          <a:p>
+            <a:pPr indent="0" marL="0">
+              <a:buNone/>
+            </a:pPr>
+            <a:r>
+              <a:rPr lang="en-US" sz="1600" b="1" dirty="0">
+                <a:solidFill>
+                  <a:srgbClr val="FFFFFF"/>
+                </a:solidFill>
+                <a:latin typeface="Calibri" pitchFamily="34" charset="0"/>
+                <a:ea typeface="Calibri" pitchFamily="34" charset="-122"/>
+                <a:cs typeface="Calibri" pitchFamily="34" charset="-120"/>
+              </a:rPr>
+              <a:t>Booth</a:t>
+            </a:r>
+            <a:endParaRPr lang="en-US" sz="1600" dirty="0"/>
+          </a:p>
+        </p:txBody>
+      </p:sp>
+      <p:sp>
+        <p:nvSpPr>
+          <p:cNvPr id="24" name="Text 19"/>
+          <p:cNvSpPr txBox="1"/>
+          <p:nvPr/>
+        </p:nvSpPr>
+        <p:spPr>
+          <a:xfrm>
+            <a:off x="4823460" y="3346704"/>
+            <a:ext cx="1851660" cy="365760"/>
+          </a:xfrm>
+          <a:prstGeom prst="rect">
+            <a:avLst/>
+          </a:prstGeom>
+          <a:noFill/>
+          <a:ln/>
+        </p:spPr>
+        <p:txBody>
+          <a:bodyPr wrap="square" lIns="0" tIns="0" rIns="0" bIns="0" rtlCol="0" anchor="t"/>
+          <a:lstStyle/>
+          <a:p>
+            <a:pPr indent="0" marL="0">
+              <a:buNone/>
+            </a:pPr>
+            <a:r>
+              <a:rPr lang="en-US" sz="1200" dirty="0">
+                <a:solidFill>
+                  <a:srgbClr val="C3CEDD"/>
+                </a:solidFill>
+                <a:latin typeface="Calibri" pitchFamily="34" charset="0"/>
+                <a:ea typeface="Calibri" pitchFamily="34" charset="-122"/>
+                <a:cs typeface="Calibri" pitchFamily="34" charset="-120"/>
+              </a:rPr>
+              <a:t>Kaunter jualan di lokasi tumpuan.</a:t>
+            </a:r>
+            <a:endParaRPr lang="en-US" sz="1200" dirty="0"/>
+          </a:p>
+        </p:txBody>
+      </p:sp>
+      <p:sp>
+        <p:nvSpPr>
+          <p:cNvPr id="25" name="Shape 20"/>
+          <p:cNvSpPr/>
+          <p:nvPr/>
+        </p:nvSpPr>
+        <p:spPr>
+          <a:xfrm>
+            <a:off x="868680" y="4023360"/>
+            <a:ext cx="2857500" cy="1005840"/>
+          </a:xfrm>
+          <a:prstGeom prst="roundRect">
+            <a:avLst>
+              <a:gd name="adj" fmla="val 7273"/>
+            </a:avLst>
+          </a:prstGeom>
+          <a:solidFill>
+            <a:srgbClr val="17325A"/>
+          </a:solidFill>
+          <a:ln w="9525">
+            <a:solidFill>
+              <a:srgbClr val="23436F"/>
+            </a:solidFill>
+            <a:prstDash val="solid"/>
+          </a:ln>
+        </p:spPr>
+      </p:sp>
+      <p:sp>
+        <p:nvSpPr>
+          <p:cNvPr id="26" name="Shape 21"/>
+          <p:cNvSpPr/>
+          <p:nvPr/>
+        </p:nvSpPr>
+        <p:spPr>
+          <a:xfrm>
+            <a:off x="1069848" y="4270248"/>
+            <a:ext cx="512064" cy="512064"/>
+          </a:xfrm>
+          <a:prstGeom prst="roundRect">
+            <a:avLst>
+              <a:gd name="adj" fmla="val 22000"/>
+            </a:avLst>
+          </a:prstGeom>
+          <a:solidFill>
+            <a:srgbClr val="23436F"/>
+          </a:solidFill>
+          <a:ln w="12700">
+            <a:solidFill>
+              <a:srgbClr val="23436F"/>
+            </a:solidFill>
+            <a:prstDash val="solid"/>
+          </a:ln>
+        </p:spPr>
+      </p:sp>
+      <p:pic>
+        <p:nvPicPr>
+          <p:cNvPr id="27" name="Image 3" descr="preencoded.png">    </p:cNvPr>
+          <p:cNvPicPr>
+            <a:picLocks noChangeAspect="1"/>
+          </p:cNvPicPr>
+          <p:nvPr/>
+        </p:nvPicPr>
+        <p:blipFill>
+          <a:blip r:embed="rId4"/>
+          <a:stretch>
+            <a:fillRect/>
+          </a:stretch>
+        </p:blipFill>
+        <p:spPr>
+          <a:xfrm>
+            <a:off x="1192743" y="4393143"/>
+            <a:ext cx="266273" cy="266273"/>
+          </a:xfrm>
+          <a:prstGeom prst="rect">
+            <a:avLst/>
+          </a:prstGeom>
+        </p:spPr>
+      </p:pic>
+      <p:sp>
+        <p:nvSpPr>
+          <p:cNvPr id="28" name="Text 22"/>
+          <p:cNvSpPr txBox="1"/>
+          <p:nvPr/>
+        </p:nvSpPr>
+        <p:spPr>
+          <a:xfrm>
+            <a:off x="1737360" y="4187952"/>
+            <a:ext cx="1851660" cy="347472"/>
+          </a:xfrm>
+          <a:prstGeom prst="rect">
+            <a:avLst/>
+          </a:prstGeom>
+          <a:noFill/>
+          <a:ln/>
+        </p:spPr>
+        <p:txBody>
+          <a:bodyPr wrap="square" lIns="0" tIns="0" rIns="0" bIns="0" rtlCol="0" anchor="ctr"/>
+          <a:lstStyle/>
+          <a:p>
+            <a:pPr indent="0" marL="0">
+              <a:buNone/>
+            </a:pPr>
+            <a:r>
+              <a:rPr lang="en-US" sz="1600" b="1" dirty="0">
+                <a:solidFill>
+                  <a:srgbClr val="FFFFFF"/>
+                </a:solidFill>
+                <a:latin typeface="Calibri" pitchFamily="34" charset="0"/>
+                <a:ea typeface="Calibri" pitchFamily="34" charset="-122"/>
+                <a:cs typeface="Calibri" pitchFamily="34" charset="-120"/>
+              </a:rPr>
+              <a:t>Poster</a:t>
+            </a:r>
+            <a:endParaRPr lang="en-US" sz="1600" dirty="0"/>
+          </a:p>
+        </p:txBody>
+      </p:sp>
+      <p:sp>
+        <p:nvSpPr>
+          <p:cNvPr id="29" name="Text 23"/>
+          <p:cNvSpPr txBox="1"/>
+          <p:nvPr/>
+        </p:nvSpPr>
+        <p:spPr>
+          <a:xfrm>
+            <a:off x="1737360" y="4535424"/>
+            <a:ext cx="1851660" cy="365760"/>
+          </a:xfrm>
+          <a:prstGeom prst="rect">
+            <a:avLst/>
+          </a:prstGeom>
+          <a:noFill/>
+          <a:ln/>
+        </p:spPr>
+        <p:txBody>
+          <a:bodyPr wrap="square" lIns="0" tIns="0" rIns="0" bIns="0" rtlCol="0" anchor="t"/>
+          <a:lstStyle/>
+          <a:p>
+            <a:pPr indent="0" marL="0">
+              <a:buNone/>
+            </a:pPr>
+            <a:r>
+              <a:rPr lang="en-US" sz="1200" dirty="0">
+                <a:solidFill>
+                  <a:srgbClr val="C3CEDD"/>
+                </a:solidFill>
+                <a:latin typeface="Calibri" pitchFamily="34" charset="0"/>
+                <a:ea typeface="Calibri" pitchFamily="34" charset="-122"/>
+                <a:cs typeface="Calibri" pitchFamily="34" charset="-120"/>
+              </a:rPr>
+              <a:t>Termasuk poster blitz di pangsapuri dan taman.</a:t>
+            </a:r>
+            <a:endParaRPr lang="en-US" sz="1200" dirty="0"/>
+          </a:p>
+        </p:txBody>
+      </p:sp>
+      <p:sp>
+        <p:nvSpPr>
+          <p:cNvPr id="30" name="Shape 24"/>
+          <p:cNvSpPr/>
+          <p:nvPr/>
+        </p:nvSpPr>
+        <p:spPr>
+          <a:xfrm>
+            <a:off x="3954780" y="4023360"/>
+            <a:ext cx="2857500" cy="1005840"/>
+          </a:xfrm>
+          <a:prstGeom prst="roundRect">
+            <a:avLst>
+              <a:gd name="adj" fmla="val 7273"/>
+            </a:avLst>
+          </a:prstGeom>
+          <a:solidFill>
+            <a:srgbClr val="17325A"/>
+          </a:solidFill>
+          <a:ln w="9525">
+            <a:solidFill>
+              <a:srgbClr val="23436F"/>
+            </a:solidFill>
+            <a:prstDash val="solid"/>
+          </a:ln>
+        </p:spPr>
+      </p:sp>
+      <p:sp>
+        <p:nvSpPr>
+          <p:cNvPr id="31" name="Shape 25"/>
+          <p:cNvSpPr/>
+          <p:nvPr/>
+        </p:nvSpPr>
+        <p:spPr>
+          <a:xfrm>
+            <a:off x="4155948" y="4270248"/>
+            <a:ext cx="512064" cy="512064"/>
+          </a:xfrm>
+          <a:prstGeom prst="roundRect">
+            <a:avLst>
+              <a:gd name="adj" fmla="val 22000"/>
+            </a:avLst>
+          </a:prstGeom>
+          <a:solidFill>
+            <a:srgbClr val="23436F"/>
+          </a:solidFill>
+          <a:ln w="12700">
+            <a:solidFill>
+              <a:srgbClr val="23436F"/>
+            </a:solidFill>
+            <a:prstDash val="solid"/>
+          </a:ln>
+        </p:spPr>
+      </p:sp>
+      <p:pic>
+        <p:nvPicPr>
+          <p:cNvPr id="32" name="Image 4" descr="preencoded.png">    </p:cNvPr>
+          <p:cNvPicPr>
+            <a:picLocks noChangeAspect="1"/>
+          </p:cNvPicPr>
+          <p:nvPr/>
+        </p:nvPicPr>
+        <p:blipFill>
+          <a:blip r:embed="rId5"/>
+          <a:stretch>
+            <a:fillRect/>
+          </a:stretch>
+        </p:blipFill>
+        <p:spPr>
+          <a:xfrm>
+            <a:off x="4278843" y="4393143"/>
+            <a:ext cx="266273" cy="266273"/>
+          </a:xfrm>
+          <a:prstGeom prst="rect">
+            <a:avLst/>
+          </a:prstGeom>
+        </p:spPr>
+      </p:pic>
+      <p:sp>
+        <p:nvSpPr>
+          <p:cNvPr id="33" name="Text 26"/>
+          <p:cNvSpPr txBox="1"/>
+          <p:nvPr/>
+        </p:nvSpPr>
+        <p:spPr>
+          <a:xfrm>
+            <a:off x="4823460" y="4187952"/>
+            <a:ext cx="1851660" cy="347472"/>
+          </a:xfrm>
+          <a:prstGeom prst="rect">
+            <a:avLst/>
+          </a:prstGeom>
+          <a:noFill/>
+          <a:ln/>
+        </p:spPr>
+        <p:txBody>
+          <a:bodyPr wrap="square" lIns="0" tIns="0" rIns="0" bIns="0" rtlCol="0" anchor="ctr"/>
+          <a:lstStyle/>
+          <a:p>
+            <a:pPr indent="0" marL="0">
+              <a:buNone/>
+            </a:pPr>
+            <a:r>
+              <a:rPr lang="en-US" sz="1600" b="1" dirty="0">
+                <a:solidFill>
+                  <a:srgbClr val="FFFFFF"/>
+                </a:solidFill>
+                <a:latin typeface="Calibri" pitchFamily="34" charset="0"/>
+                <a:ea typeface="Calibri" pitchFamily="34" charset="-122"/>
+                <a:cs typeface="Calibri" pitchFamily="34" charset="-120"/>
+              </a:rPr>
+              <a:t>Referral customer</a:t>
+            </a:r>
+            <a:endParaRPr lang="en-US" sz="1600" dirty="0"/>
+          </a:p>
+        </p:txBody>
+      </p:sp>
+      <p:sp>
+        <p:nvSpPr>
+          <p:cNvPr id="34" name="Text 27"/>
+          <p:cNvSpPr txBox="1"/>
+          <p:nvPr/>
+        </p:nvSpPr>
+        <p:spPr>
+          <a:xfrm>
+            <a:off x="4823460" y="4535424"/>
+            <a:ext cx="1851660" cy="365760"/>
+          </a:xfrm>
+          <a:prstGeom prst="rect">
+            <a:avLst/>
+          </a:prstGeom>
+          <a:noFill/>
+          <a:ln/>
+        </p:spPr>
+        <p:txBody>
+          <a:bodyPr wrap="square" lIns="0" tIns="0" rIns="0" bIns="0" rtlCol="0" anchor="t"/>
+          <a:lstStyle/>
+          <a:p>
+            <a:pPr indent="0" marL="0">
+              <a:buNone/>
+            </a:pPr>
+            <a:r>
+              <a:rPr lang="en-US" sz="1200" dirty="0">
+                <a:solidFill>
+                  <a:srgbClr val="C3CEDD"/>
+                </a:solidFill>
+                <a:latin typeface="Calibri" pitchFamily="34" charset="0"/>
+                <a:ea typeface="Calibri" pitchFamily="34" charset="-122"/>
+                <a:cs typeface="Calibri" pitchFamily="34" charset="-120"/>
+              </a:rPr>
+              <a:t>Jiran dan kawan customer yang puas hati.</a:t>
+            </a:r>
+            <a:endParaRPr lang="en-US" sz="1200" dirty="0"/>
+          </a:p>
+        </p:txBody>
+      </p:sp>
+      <p:sp>
+        <p:nvSpPr>
+          <p:cNvPr id="35" name="Shape 28"/>
+          <p:cNvSpPr/>
+          <p:nvPr/>
+        </p:nvSpPr>
+        <p:spPr>
+          <a:xfrm>
+            <a:off x="7406640" y="1600200"/>
+            <a:ext cx="4236415" cy="3749040"/>
           </a:xfrm>
           <a:prstGeom prst="roundRect">
             <a:avLst>
@@ -25920,13 +26773,13 @@
       </p:sp>
       <p:sp>
         <p:nvSpPr>
-          <p:cNvPr id="9" name="Shape 7"/>
+          <p:cNvPr id="36" name="Shape 29"/>
           <p:cNvSpPr/>
           <p:nvPr/>
         </p:nvSpPr>
         <p:spPr>
           <a:xfrm>
-            <a:off x="868680" y="1920240"/>
+            <a:off x="7726680" y="1920240"/>
             <a:ext cx="640080" cy="640080"/>
           </a:xfrm>
           <a:prstGeom prst="roundRect">
@@ -25947,21 +26800,21 @@
       </p:sp>
       <p:pic>
         <p:nvPicPr>
-          <p:cNvPr id="10" name="Image 0" descr="preencoded.png">    </p:cNvPr>
+          <p:cNvPr id="37" name="Image 5" descr="preencoded.png">    </p:cNvPr>
           <p:cNvPicPr>
             <a:picLocks noChangeAspect="1"/>
           </p:cNvPicPr>
           <p:nvPr/>
         </p:nvPicPr>
         <p:blipFill>
-          <a:blip r:embed="rId1"/>
+          <a:blip r:embed="rId6"/>
           <a:stretch>
             <a:fillRect/>
           </a:stretch>
         </p:blipFill>
         <p:spPr>
           <a:xfrm>
-            <a:off x="1022299" y="2073859"/>
+            <a:off x="7880299" y="2073859"/>
             <a:ext cx="332842" cy="332842"/>
           </a:xfrm>
           <a:prstGeom prst="rect">
@@ -25971,14 +26824,14 @@
       </p:pic>
       <p:sp>
         <p:nvSpPr>
-          <p:cNvPr id="11" name="Text 8"/>
-          <p:cNvSpPr txBox="1"/>
-          <p:nvPr/>
-        </p:nvSpPr>
-        <p:spPr>
-          <a:xfrm>
-            <a:off x="1691640" y="1920240"/>
-            <a:ext cx="2743200" cy="256032"/>
+          <p:cNvPr id="38" name="Text 30"/>
+          <p:cNvSpPr txBox="1"/>
+          <p:nvPr/>
+        </p:nvSpPr>
+        <p:spPr>
+          <a:xfrm>
+            <a:off x="8549640" y="1920240"/>
+            <a:ext cx="2956255" cy="256032"/>
           </a:xfrm>
           <a:prstGeom prst="rect">
             <a:avLst/>
@@ -25994,7 +26847,7 @@
               <a:buNone/>
             </a:pPr>
             <a:r>
-              <a:rPr lang="en-US" sz="1100" b="1" spc="200" kern="0" dirty="0">
+              <a:rPr lang="en-US" sz="1000" b="1" spc="100" kern="0" dirty="0">
                 <a:solidFill>
                   <a:srgbClr val="C8742B"/>
                 </a:solidFill>
@@ -26002,22 +26855,22 @@
                 <a:ea typeface="Calibri" pitchFamily="34" charset="-122"/>
                 <a:cs typeface="Calibri" pitchFamily="34" charset="-120"/>
               </a:rPr>
-              <a:t>SALURAN 01</a:t>
-            </a:r>
-            <a:endParaRPr lang="en-US" sz="1100" dirty="0"/>
-          </a:p>
-        </p:txBody>
-      </p:sp>
-      <p:sp>
-        <p:nvSpPr>
-          <p:cNvPr id="12" name="Text 9"/>
-          <p:cNvSpPr txBox="1"/>
-          <p:nvPr/>
-        </p:nvSpPr>
-        <p:spPr>
-          <a:xfrm>
-            <a:off x="1691640" y="2167128"/>
-            <a:ext cx="3200400" cy="411480"/>
+              <a:t>SALURAN 02  ·  SUMBER TAMBAHAN</a:t>
+            </a:r>
+            <a:endParaRPr lang="en-US" sz="1000" dirty="0"/>
+          </a:p>
+        </p:txBody>
+      </p:sp>
+      <p:sp>
+        <p:nvSpPr>
+          <p:cNvPr id="39" name="Text 31"/>
+          <p:cNvSpPr txBox="1"/>
+          <p:nvPr/>
+        </p:nvSpPr>
+        <p:spPr>
+          <a:xfrm>
+            <a:off x="8549640" y="2167128"/>
+            <a:ext cx="2011680" cy="411480"/>
           </a:xfrm>
           <a:prstGeom prst="rect">
             <a:avLst/>
@@ -26041,7 +26894,7 @@
                 <a:ea typeface="Calibri" pitchFamily="34" charset="-122"/>
                 <a:cs typeface="Calibri" pitchFamily="34" charset="-120"/>
               </a:rPr>
-              <a:t>Ground sales</a:t>
+              <a:t>Digital</a:t>
             </a:r>
             <a:endParaRPr lang="en-US" sz="2400" dirty="0"/>
           </a:p>
@@ -26049,18 +26902,18 @@
       </p:sp>
       <p:sp>
         <p:nvSpPr>
-          <p:cNvPr id="13" name="Shape 10"/>
+          <p:cNvPr id="40" name="Shape 32"/>
           <p:cNvSpPr/>
           <p:nvPr/>
         </p:nvSpPr>
         <p:spPr>
           <a:xfrm>
-            <a:off x="868680" y="2935224"/>
-            <a:ext cx="457200" cy="457200"/>
+            <a:off x="10180015" y="2240280"/>
+            <a:ext cx="1143000" cy="292608"/>
           </a:xfrm>
           <a:prstGeom prst="roundRect">
             <a:avLst>
-              <a:gd name="adj" fmla="val 22000"/>
+              <a:gd name="adj" fmla="val 50000"/>
             </a:avLst>
           </a:prstGeom>
           <a:solidFill>
@@ -26074,40 +26927,16 @@
           </a:ln>
         </p:spPr>
       </p:sp>
-      <p:pic>
-        <p:nvPicPr>
-          <p:cNvPr id="14" name="Image 1" descr="preencoded.png">    </p:cNvPr>
-          <p:cNvPicPr>
-            <a:picLocks noChangeAspect="1"/>
-          </p:cNvPicPr>
-          <p:nvPr/>
-        </p:nvPicPr>
-        <p:blipFill>
-          <a:blip r:embed="rId2"/>
-          <a:stretch>
-            <a:fillRect/>
-          </a:stretch>
-        </p:blipFill>
-        <p:spPr>
-          <a:xfrm>
-            <a:off x="978408" y="3044952"/>
-            <a:ext cx="237744" cy="237744"/>
-          </a:xfrm>
-          <a:prstGeom prst="rect">
-            <a:avLst/>
-          </a:prstGeom>
-        </p:spPr>
-      </p:pic>
-      <p:sp>
-        <p:nvSpPr>
-          <p:cNvPr id="15" name="Text 11"/>
-          <p:cNvSpPr txBox="1"/>
-          <p:nvPr/>
-        </p:nvSpPr>
-        <p:spPr>
-          <a:xfrm>
-            <a:off x="1508760" y="2880360"/>
-            <a:ext cx="3337560" cy="310896"/>
+      <p:sp>
+        <p:nvSpPr>
+          <p:cNvPr id="41" name="Text 33"/>
+          <p:cNvSpPr txBox="1"/>
+          <p:nvPr/>
+        </p:nvSpPr>
+        <p:spPr>
+          <a:xfrm>
+            <a:off x="10180015" y="2240280"/>
+            <a:ext cx="1143000" cy="292608"/>
           </a:xfrm>
           <a:prstGeom prst="rect">
             <a:avLst/>
@@ -26119,11 +26948,11 @@
           <a:bodyPr wrap="square" lIns="0" tIns="0" rIns="0" bIns="0" rtlCol="0" anchor="ctr"/>
           <a:lstStyle/>
           <a:p>
-            <a:pPr indent="0" marL="0">
-              <a:buNone/>
-            </a:pPr>
-            <a:r>
-              <a:rPr lang="en-US" sz="1500" b="1" dirty="0">
+            <a:pPr algn="ctr" indent="0" marL="0">
+              <a:buNone/>
+            </a:pPr>
+            <a:r>
+              <a:rPr lang="en-US" sz="1100" b="1" dirty="0">
                 <a:solidFill>
                   <a:srgbClr val="0B1F3A"/>
                 </a:solidFill>
@@ -26131,369 +26960,26 @@
                 <a:ea typeface="Calibri" pitchFamily="34" charset="-122"/>
                 <a:cs typeface="Calibri" pitchFamily="34" charset="-120"/>
               </a:rPr>
-              <a:t>Poster di kawasan perumahan</a:t>
-            </a:r>
-            <a:endParaRPr lang="en-US" sz="1500" dirty="0"/>
-          </a:p>
-        </p:txBody>
-      </p:sp>
-      <p:sp>
-        <p:nvSpPr>
-          <p:cNvPr id="16" name="Text 12"/>
-          <p:cNvSpPr txBox="1"/>
-          <p:nvPr/>
-        </p:nvSpPr>
-        <p:spPr>
-          <a:xfrm>
-            <a:off x="1508760" y="3191256"/>
-            <a:ext cx="3337560" cy="292608"/>
-          </a:xfrm>
-          <a:prstGeom prst="rect">
-            <a:avLst/>
-          </a:prstGeom>
-          <a:noFill/>
-          <a:ln/>
-        </p:spPr>
-        <p:txBody>
-          <a:bodyPr wrap="square" lIns="0" tIns="0" rIns="0" bIns="0" rtlCol="0" anchor="ctr"/>
-          <a:lstStyle/>
-          <a:p>
-            <a:pPr indent="0" marL="0">
-              <a:buNone/>
-            </a:pPr>
-            <a:r>
-              <a:rPr lang="en-US" sz="1250" dirty="0">
-                <a:solidFill>
-                  <a:srgbClr val="5B6B80"/>
-                </a:solidFill>
-                <a:latin typeface="Calibri" pitchFamily="34" charset="0"/>
-                <a:ea typeface="Calibri" pitchFamily="34" charset="-122"/>
-                <a:cs typeface="Calibri" pitchFamily="34" charset="-120"/>
-              </a:rPr>
-              <a:t>Bawa lead, tetapi belum direkod berapa banyak.</a:t>
-            </a:r>
-            <a:endParaRPr lang="en-US" sz="1250" dirty="0"/>
-          </a:p>
-        </p:txBody>
-      </p:sp>
-      <p:sp>
-        <p:nvSpPr>
-          <p:cNvPr id="17" name="Shape 13"/>
+              <a:t>Selebihnya</a:t>
+            </a:r>
+            <a:endParaRPr lang="en-US" sz="1100" dirty="0"/>
+          </a:p>
+        </p:txBody>
+      </p:sp>
+      <p:sp>
+        <p:nvSpPr>
+          <p:cNvPr id="42" name="Shape 34"/>
           <p:cNvSpPr/>
           <p:nvPr/>
         </p:nvSpPr>
         <p:spPr>
           <a:xfrm>
-            <a:off x="868680" y="3593592"/>
-            <a:ext cx="3931920" cy="0"/>
-          </a:xfrm>
-          <a:prstGeom prst="line">
-            <a:avLst/>
-          </a:prstGeom>
-          <a:noFill/>
-          <a:ln w="9525">
-            <a:solidFill>
-              <a:srgbClr val="D8E0EA"/>
-            </a:solidFill>
-            <a:prstDash val="solid"/>
-          </a:ln>
-        </p:spPr>
-      </p:sp>
-      <p:sp>
-        <p:nvSpPr>
-          <p:cNvPr id="18" name="Shape 14"/>
-          <p:cNvSpPr/>
-          <p:nvPr/>
-        </p:nvSpPr>
-        <p:spPr>
-          <a:xfrm>
-            <a:off x="868680" y="3739896"/>
-            <a:ext cx="457200" cy="457200"/>
-          </a:xfrm>
-          <a:prstGeom prst="roundRect">
+            <a:off x="7726680" y="2907792"/>
+            <a:ext cx="475488" cy="475488"/>
+          </a:xfrm>
+          <a:prstGeom prst="ellipse">
             <a:avLst>
               <a:gd name="adj" fmla="val 22000"/>
-            </a:avLst>
-          </a:prstGeom>
-          <a:solidFill>
-            <a:srgbClr val="EBF0F6"/>
-          </a:solidFill>
-          <a:ln w="12700">
-            <a:solidFill>
-              <a:srgbClr val="EBF0F6"/>
-            </a:solidFill>
-            <a:prstDash val="solid"/>
-          </a:ln>
-        </p:spPr>
-      </p:sp>
-      <p:pic>
-        <p:nvPicPr>
-          <p:cNvPr id="19" name="Image 2" descr="preencoded.png">    </p:cNvPr>
-          <p:cNvPicPr>
-            <a:picLocks noChangeAspect="1"/>
-          </p:cNvPicPr>
-          <p:nvPr/>
-        </p:nvPicPr>
-        <p:blipFill>
-          <a:blip r:embed="rId3"/>
-          <a:stretch>
-            <a:fillRect/>
-          </a:stretch>
-        </p:blipFill>
-        <p:spPr>
-          <a:xfrm>
-            <a:off x="978408" y="3849624"/>
-            <a:ext cx="237744" cy="237744"/>
-          </a:xfrm>
-          <a:prstGeom prst="rect">
-            <a:avLst/>
-          </a:prstGeom>
-        </p:spPr>
-      </p:pic>
-      <p:sp>
-        <p:nvSpPr>
-          <p:cNvPr id="20" name="Text 15"/>
-          <p:cNvSpPr txBox="1"/>
-          <p:nvPr/>
-        </p:nvSpPr>
-        <p:spPr>
-          <a:xfrm>
-            <a:off x="1508760" y="3685032"/>
-            <a:ext cx="3337560" cy="310896"/>
-          </a:xfrm>
-          <a:prstGeom prst="rect">
-            <a:avLst/>
-          </a:prstGeom>
-          <a:noFill/>
-          <a:ln/>
-        </p:spPr>
-        <p:txBody>
-          <a:bodyPr wrap="square" lIns="0" tIns="0" rIns="0" bIns="0" rtlCol="0" anchor="ctr"/>
-          <a:lstStyle/>
-          <a:p>
-            <a:pPr indent="0" marL="0">
-              <a:buNone/>
-            </a:pPr>
-            <a:r>
-              <a:rPr lang="en-US" sz="1500" b="1" dirty="0">
-                <a:solidFill>
-                  <a:srgbClr val="0B1F3A"/>
-                </a:solidFill>
-                <a:latin typeface="Calibri" pitchFamily="34" charset="0"/>
-                <a:ea typeface="Calibri" pitchFamily="34" charset="-122"/>
-                <a:cs typeface="Calibri" pitchFamily="34" charset="-120"/>
-              </a:rPr>
-              <a:t>Referral customer</a:t>
-            </a:r>
-            <a:endParaRPr lang="en-US" sz="1500" dirty="0"/>
-          </a:p>
-        </p:txBody>
-      </p:sp>
-      <p:sp>
-        <p:nvSpPr>
-          <p:cNvPr id="21" name="Text 16"/>
-          <p:cNvSpPr txBox="1"/>
-          <p:nvPr/>
-        </p:nvSpPr>
-        <p:spPr>
-          <a:xfrm>
-            <a:off x="1508760" y="3995928"/>
-            <a:ext cx="3337560" cy="292608"/>
-          </a:xfrm>
-          <a:prstGeom prst="rect">
-            <a:avLst/>
-          </a:prstGeom>
-          <a:noFill/>
-          <a:ln/>
-        </p:spPr>
-        <p:txBody>
-          <a:bodyPr wrap="square" lIns="0" tIns="0" rIns="0" bIns="0" rtlCol="0" anchor="ctr"/>
-          <a:lstStyle/>
-          <a:p>
-            <a:pPr indent="0" marL="0">
-              <a:buNone/>
-            </a:pPr>
-            <a:r>
-              <a:rPr lang="en-US" sz="1250" dirty="0">
-                <a:solidFill>
-                  <a:srgbClr val="5B6B80"/>
-                </a:solidFill>
-                <a:latin typeface="Calibri" pitchFamily="34" charset="0"/>
-                <a:ea typeface="Calibri" pitchFamily="34" charset="-122"/>
-                <a:cs typeface="Calibri" pitchFamily="34" charset="-120"/>
-              </a:rPr>
-              <a:t>Jiran dan kawan customer yang puas hati.</a:t>
-            </a:r>
-            <a:endParaRPr lang="en-US" sz="1250" dirty="0"/>
-          </a:p>
-        </p:txBody>
-      </p:sp>
-      <p:sp>
-        <p:nvSpPr>
-          <p:cNvPr id="22" name="Shape 17"/>
-          <p:cNvSpPr/>
-          <p:nvPr/>
-        </p:nvSpPr>
-        <p:spPr>
-          <a:xfrm>
-            <a:off x="868680" y="4398264"/>
-            <a:ext cx="3931920" cy="0"/>
-          </a:xfrm>
-          <a:prstGeom prst="line">
-            <a:avLst/>
-          </a:prstGeom>
-          <a:noFill/>
-          <a:ln w="9525">
-            <a:solidFill>
-              <a:srgbClr val="D8E0EA"/>
-            </a:solidFill>
-            <a:prstDash val="solid"/>
-          </a:ln>
-        </p:spPr>
-      </p:sp>
-      <p:sp>
-        <p:nvSpPr>
-          <p:cNvPr id="23" name="Shape 18"/>
-          <p:cNvSpPr/>
-          <p:nvPr/>
-        </p:nvSpPr>
-        <p:spPr>
-          <a:xfrm>
-            <a:off x="868680" y="4544568"/>
-            <a:ext cx="457200" cy="457200"/>
-          </a:xfrm>
-          <a:prstGeom prst="roundRect">
-            <a:avLst>
-              <a:gd name="adj" fmla="val 22000"/>
-            </a:avLst>
-          </a:prstGeom>
-          <a:solidFill>
-            <a:srgbClr val="EBF0F6"/>
-          </a:solidFill>
-          <a:ln w="12700">
-            <a:solidFill>
-              <a:srgbClr val="EBF0F6"/>
-            </a:solidFill>
-            <a:prstDash val="solid"/>
-          </a:ln>
-        </p:spPr>
-      </p:sp>
-      <p:pic>
-        <p:nvPicPr>
-          <p:cNvPr id="24" name="Image 3" descr="preencoded.png">    </p:cNvPr>
-          <p:cNvPicPr>
-            <a:picLocks noChangeAspect="1"/>
-          </p:cNvPicPr>
-          <p:nvPr/>
-        </p:nvPicPr>
-        <p:blipFill>
-          <a:blip r:embed="rId4"/>
-          <a:stretch>
-            <a:fillRect/>
-          </a:stretch>
-        </p:blipFill>
-        <p:spPr>
-          <a:xfrm>
-            <a:off x="978408" y="4654296"/>
-            <a:ext cx="237744" cy="237744"/>
-          </a:xfrm>
-          <a:prstGeom prst="rect">
-            <a:avLst/>
-          </a:prstGeom>
-        </p:spPr>
-      </p:pic>
-      <p:sp>
-        <p:nvSpPr>
-          <p:cNvPr id="25" name="Text 19"/>
-          <p:cNvSpPr txBox="1"/>
-          <p:nvPr/>
-        </p:nvSpPr>
-        <p:spPr>
-          <a:xfrm>
-            <a:off x="1508760" y="4489704"/>
-            <a:ext cx="3337560" cy="310896"/>
-          </a:xfrm>
-          <a:prstGeom prst="rect">
-            <a:avLst/>
-          </a:prstGeom>
-          <a:noFill/>
-          <a:ln/>
-        </p:spPr>
-        <p:txBody>
-          <a:bodyPr wrap="square" lIns="0" tIns="0" rIns="0" bIns="0" rtlCol="0" anchor="ctr"/>
-          <a:lstStyle/>
-          <a:p>
-            <a:pPr indent="0" marL="0">
-              <a:buNone/>
-            </a:pPr>
-            <a:r>
-              <a:rPr lang="en-US" sz="1500" b="1" dirty="0">
-                <a:solidFill>
-                  <a:srgbClr val="0B1F3A"/>
-                </a:solidFill>
-                <a:latin typeface="Calibri" pitchFamily="34" charset="0"/>
-                <a:ea typeface="Calibri" pitchFamily="34" charset="-122"/>
-                <a:cs typeface="Calibri" pitchFamily="34" charset="-120"/>
-              </a:rPr>
-              <a:t>Poster blitz hujung minggu</a:t>
-            </a:r>
-            <a:endParaRPr lang="en-US" sz="1500" dirty="0"/>
-          </a:p>
-        </p:txBody>
-      </p:sp>
-      <p:sp>
-        <p:nvSpPr>
-          <p:cNvPr id="26" name="Text 20"/>
-          <p:cNvSpPr txBox="1"/>
-          <p:nvPr/>
-        </p:nvSpPr>
-        <p:spPr>
-          <a:xfrm>
-            <a:off x="1508760" y="4800600"/>
-            <a:ext cx="3337560" cy="292608"/>
-          </a:xfrm>
-          <a:prstGeom prst="rect">
-            <a:avLst/>
-          </a:prstGeom>
-          <a:noFill/>
-          <a:ln/>
-        </p:spPr>
-        <p:txBody>
-          <a:bodyPr wrap="square" lIns="0" tIns="0" rIns="0" bIns="0" rtlCol="0" anchor="ctr"/>
-          <a:lstStyle/>
-          <a:p>
-            <a:pPr indent="0" marL="0">
-              <a:buNone/>
-            </a:pPr>
-            <a:r>
-              <a:rPr lang="en-US" sz="1250" dirty="0">
-                <a:solidFill>
-                  <a:srgbClr val="5B6B80"/>
-                </a:solidFill>
-                <a:latin typeface="Calibri" pitchFamily="34" charset="0"/>
-                <a:ea typeface="Calibri" pitchFamily="34" charset="-122"/>
-                <a:cs typeface="Calibri" pitchFamily="34" charset="-120"/>
-              </a:rPr>
-              <a:t>Pangsapuri dan taman baru, dengan nombor sendiri.</a:t>
-            </a:r>
-            <a:endParaRPr lang="en-US" sz="1250" dirty="0"/>
-          </a:p>
-        </p:txBody>
-      </p:sp>
-      <p:sp>
-        <p:nvSpPr>
-          <p:cNvPr id="27" name="Shape 21"/>
-          <p:cNvSpPr/>
-          <p:nvPr/>
-        </p:nvSpPr>
-        <p:spPr>
-          <a:xfrm>
-            <a:off x="5394960" y="1600200"/>
-            <a:ext cx="6248095" cy="3749040"/>
-          </a:xfrm>
-          <a:prstGeom prst="roundRect">
-            <a:avLst>
-              <a:gd name="adj" fmla="val 1951"/>
             </a:avLst>
           </a:prstGeom>
           <a:solidFill>
@@ -26505,29 +26991,85 @@
             </a:solidFill>
             <a:prstDash val="solid"/>
           </a:ln>
-          <a:effectLst>
-            <a:outerShdw sx="100000" sy="100000" kx="0" ky="0" algn="bl" rotWithShape="0" blurRad="127000" dist="25400" dir="5400000">
-              <a:srgbClr val="0B1F3A">
-                <a:alpha val="10000"/>
-              </a:srgbClr>
-            </a:outerShdw>
-          </a:effectLst>
-        </p:spPr>
-      </p:sp>
-      <p:sp>
-        <p:nvSpPr>
-          <p:cNvPr id="28" name="Shape 22"/>
+        </p:spPr>
+      </p:sp>
+      <p:pic>
+        <p:nvPicPr>
+          <p:cNvPr id="43" name="Image 6" descr="preencoded.png">    </p:cNvPr>
+          <p:cNvPicPr>
+            <a:picLocks noChangeAspect="1"/>
+          </p:cNvPicPr>
+          <p:nvPr/>
+        </p:nvPicPr>
+        <p:blipFill>
+          <a:blip r:embed="rId7"/>
+          <a:stretch>
+            <a:fillRect/>
+          </a:stretch>
+        </p:blipFill>
+        <p:spPr>
+          <a:xfrm>
+            <a:off x="7840797" y="3021909"/>
+            <a:ext cx="247254" cy="247254"/>
+          </a:xfrm>
+          <a:prstGeom prst="rect">
+            <a:avLst/>
+          </a:prstGeom>
+        </p:spPr>
+      </p:pic>
+      <p:sp>
+        <p:nvSpPr>
+          <p:cNvPr id="44" name="Text 35"/>
+          <p:cNvSpPr txBox="1"/>
+          <p:nvPr/>
+        </p:nvSpPr>
+        <p:spPr>
+          <a:xfrm>
+            <a:off x="8366760" y="2834640"/>
+            <a:ext cx="1463040" cy="310896"/>
+          </a:xfrm>
+          <a:prstGeom prst="rect">
+            <a:avLst/>
+          </a:prstGeom>
+          <a:noFill/>
+          <a:ln/>
+        </p:spPr>
+        <p:txBody>
+          <a:bodyPr wrap="square" lIns="0" tIns="0" rIns="0" bIns="0" rtlCol="0" anchor="ctr"/>
+          <a:lstStyle/>
+          <a:p>
+            <a:pPr indent="0" marL="0">
+              <a:buNone/>
+            </a:pPr>
+            <a:r>
+              <a:rPr lang="en-US" sz="1500" b="1" dirty="0">
+                <a:solidFill>
+                  <a:srgbClr val="0B1F3A"/>
+                </a:solidFill>
+                <a:latin typeface="Calibri" pitchFamily="34" charset="0"/>
+                <a:ea typeface="Calibri" pitchFamily="34" charset="-122"/>
+                <a:cs typeface="Calibri" pitchFamily="34" charset="-120"/>
+              </a:rPr>
+              <a:t>TikTok</a:t>
+            </a:r>
+            <a:endParaRPr lang="en-US" sz="1500" dirty="0"/>
+          </a:p>
+        </p:txBody>
+      </p:sp>
+      <p:sp>
+        <p:nvSpPr>
+          <p:cNvPr id="45" name="Shape 36"/>
           <p:cNvSpPr/>
           <p:nvPr/>
         </p:nvSpPr>
         <p:spPr>
           <a:xfrm>
-            <a:off x="5715000" y="1920240"/>
-            <a:ext cx="640080" cy="640080"/>
+            <a:off x="10362895" y="2871216"/>
+            <a:ext cx="960120" cy="246888"/>
           </a:xfrm>
           <a:prstGeom prst="roundRect">
             <a:avLst>
-              <a:gd name="adj" fmla="val 22000"/>
+              <a:gd name="adj" fmla="val 48148"/>
             </a:avLst>
           </a:prstGeom>
           <a:solidFill>
@@ -26541,79 +27083,16 @@
           </a:ln>
         </p:spPr>
       </p:sp>
-      <p:pic>
-        <p:nvPicPr>
-          <p:cNvPr id="29" name="Image 4" descr="preencoded.png">    </p:cNvPr>
-          <p:cNvPicPr>
-            <a:picLocks noChangeAspect="1"/>
-          </p:cNvPicPr>
-          <p:nvPr/>
-        </p:nvPicPr>
-        <p:blipFill>
-          <a:blip r:embed="rId5"/>
-          <a:stretch>
-            <a:fillRect/>
-          </a:stretch>
-        </p:blipFill>
-        <p:spPr>
-          <a:xfrm>
-            <a:off x="5868619" y="2073859"/>
-            <a:ext cx="332842" cy="332842"/>
-          </a:xfrm>
-          <a:prstGeom prst="rect">
-            <a:avLst/>
-          </a:prstGeom>
-        </p:spPr>
-      </p:pic>
-      <p:sp>
-        <p:nvSpPr>
-          <p:cNvPr id="30" name="Text 23"/>
-          <p:cNvSpPr txBox="1"/>
-          <p:nvPr/>
-        </p:nvSpPr>
-        <p:spPr>
-          <a:xfrm>
-            <a:off x="6537960" y="1920240"/>
-            <a:ext cx="2743200" cy="256032"/>
-          </a:xfrm>
-          <a:prstGeom prst="rect">
-            <a:avLst/>
-          </a:prstGeom>
-          <a:noFill/>
-          <a:ln/>
-        </p:spPr>
-        <p:txBody>
-          <a:bodyPr wrap="square" lIns="0" tIns="0" rIns="0" bIns="0" rtlCol="0" anchor="t"/>
-          <a:lstStyle/>
-          <a:p>
-            <a:pPr indent="0" marL="0">
-              <a:buNone/>
-            </a:pPr>
-            <a:r>
-              <a:rPr lang="en-US" sz="1100" b="1" spc="200" kern="0" dirty="0">
-                <a:solidFill>
-                  <a:srgbClr val="C8742B"/>
-                </a:solidFill>
-                <a:latin typeface="Calibri" pitchFamily="34" charset="0"/>
-                <a:ea typeface="Calibri" pitchFamily="34" charset="-122"/>
-                <a:cs typeface="Calibri" pitchFamily="34" charset="-120"/>
-              </a:rPr>
-              <a:t>SALURAN 02</a:t>
-            </a:r>
-            <a:endParaRPr lang="en-US" sz="1100" dirty="0"/>
-          </a:p>
-        </p:txBody>
-      </p:sp>
-      <p:sp>
-        <p:nvSpPr>
-          <p:cNvPr id="31" name="Text 24"/>
-          <p:cNvSpPr txBox="1"/>
-          <p:nvPr/>
-        </p:nvSpPr>
-        <p:spPr>
-          <a:xfrm>
-            <a:off x="6537960" y="2167128"/>
-            <a:ext cx="3200400" cy="411480"/>
+      <p:sp>
+        <p:nvSpPr>
+          <p:cNvPr id="46" name="Text 37"/>
+          <p:cNvSpPr txBox="1"/>
+          <p:nvPr/>
+        </p:nvSpPr>
+        <p:spPr>
+          <a:xfrm>
+            <a:off x="10362895" y="2871216"/>
+            <a:ext cx="960120" cy="246888"/>
           </a:xfrm>
           <a:prstGeom prst="rect">
             <a:avLst/>
@@ -26625,11 +27104,11 @@
           <a:bodyPr wrap="square" lIns="0" tIns="0" rIns="0" bIns="0" rtlCol="0" anchor="ctr"/>
           <a:lstStyle/>
           <a:p>
-            <a:pPr indent="0" marL="0">
-              <a:buNone/>
-            </a:pPr>
-            <a:r>
-              <a:rPr lang="en-US" sz="2400" b="1" dirty="0">
+            <a:pPr algn="ctr" indent="0" marL="0">
+              <a:buNone/>
+            </a:pPr>
+            <a:r>
+              <a:rPr lang="en-US" sz="1000" b="1" dirty="0">
                 <a:solidFill>
                   <a:srgbClr val="FFFFFF"/>
                 </a:solidFill>
@@ -26637,34 +27116,69 @@
                 <a:ea typeface="Calibri" pitchFamily="34" charset="-122"/>
                 <a:cs typeface="Calibri" pitchFamily="34" charset="-120"/>
               </a:rPr>
-              <a:t>Digital</a:t>
-            </a:r>
-            <a:endParaRPr lang="en-US" sz="2400" dirty="0"/>
-          </a:p>
-        </p:txBody>
-      </p:sp>
-      <p:sp>
-        <p:nvSpPr>
-          <p:cNvPr id="32" name="Shape 25"/>
+              <a:t>Aktif</a:t>
+            </a:r>
+            <a:endParaRPr lang="en-US" sz="1000" dirty="0"/>
+          </a:p>
+        </p:txBody>
+      </p:sp>
+      <p:sp>
+        <p:nvSpPr>
+          <p:cNvPr id="47" name="Text 38"/>
+          <p:cNvSpPr txBox="1"/>
+          <p:nvPr/>
+        </p:nvSpPr>
+        <p:spPr>
+          <a:xfrm>
+            <a:off x="8366760" y="3163824"/>
+            <a:ext cx="2956255" cy="310896"/>
+          </a:xfrm>
+          <a:prstGeom prst="rect">
+            <a:avLst/>
+          </a:prstGeom>
+          <a:noFill/>
+          <a:ln/>
+        </p:spPr>
+        <p:txBody>
+          <a:bodyPr wrap="square" lIns="0" tIns="0" rIns="0" bIns="0" rtlCol="0" anchor="ctr"/>
+          <a:lstStyle/>
+          <a:p>
+            <a:pPr indent="0" marL="0">
+              <a:buNone/>
+            </a:pPr>
+            <a:r>
+              <a:rPr lang="en-US" sz="1200" dirty="0">
+                <a:solidFill>
+                  <a:srgbClr val="5B6B80"/>
+                </a:solidFill>
+                <a:latin typeface="Calibri" pitchFamily="34" charset="0"/>
+                <a:ea typeface="Calibri" pitchFamily="34" charset="-122"/>
+                <a:cs typeface="Calibri" pitchFamily="34" charset="-120"/>
+              </a:rPr>
+              <a:t>Satu-satunya channel digital yang masih bawa jualan.</a:t>
+            </a:r>
+            <a:endParaRPr lang="en-US" sz="1200" dirty="0"/>
+          </a:p>
+        </p:txBody>
+      </p:sp>
+      <p:sp>
+        <p:nvSpPr>
+          <p:cNvPr id="48" name="Shape 39"/>
           <p:cNvSpPr/>
           <p:nvPr/>
         </p:nvSpPr>
         <p:spPr>
           <a:xfrm>
-            <a:off x="5715000" y="2834640"/>
-            <a:ext cx="1747418" cy="2240280"/>
-          </a:xfrm>
-          <a:prstGeom prst="roundRect">
-            <a:avLst>
-              <a:gd name="adj" fmla="val 4186"/>
-            </a:avLst>
-          </a:prstGeom>
-          <a:solidFill>
-            <a:srgbClr val="17325A"/>
-          </a:solidFill>
+            <a:off x="7726680" y="3566160"/>
+            <a:ext cx="3596335" cy="0"/>
+          </a:xfrm>
+          <a:prstGeom prst="line">
+            <a:avLst/>
+          </a:prstGeom>
+          <a:noFill/>
           <a:ln w="9525">
             <a:solidFill>
-              <a:srgbClr val="23436F"/>
+              <a:srgbClr val="D8E0EA"/>
             </a:solidFill>
             <a:prstDash val="solid"/>
           </a:ln>
@@ -26672,14 +27186,14 @@
       </p:sp>
       <p:sp>
         <p:nvSpPr>
-          <p:cNvPr id="33" name="Shape 26"/>
+          <p:cNvPr id="49" name="Shape 40"/>
           <p:cNvSpPr/>
           <p:nvPr/>
         </p:nvSpPr>
         <p:spPr>
           <a:xfrm>
-            <a:off x="5943600" y="3063240"/>
-            <a:ext cx="502920" cy="502920"/>
+            <a:off x="7726680" y="3730752"/>
+            <a:ext cx="475488" cy="475488"/>
           </a:xfrm>
           <a:prstGeom prst="ellipse">
             <a:avLst>
@@ -26687,11 +27201,11 @@
             </a:avLst>
           </a:prstGeom>
           <a:solidFill>
-            <a:srgbClr val="23436F"/>
+            <a:srgbClr val="0B1F3A"/>
           </a:solidFill>
           <a:ln w="12700">
             <a:solidFill>
-              <a:srgbClr val="23436F"/>
+              <a:srgbClr val="0B1F3A"/>
             </a:solidFill>
             <a:prstDash val="solid"/>
           </a:ln>
@@ -26699,451 +27213,7 @@
       </p:sp>
       <p:pic>
         <p:nvPicPr>
-          <p:cNvPr id="34" name="Image 5" descr="preencoded.png">    </p:cNvPr>
-          <p:cNvPicPr>
-            <a:picLocks noChangeAspect="1"/>
-          </p:cNvPicPr>
-          <p:nvPr/>
-        </p:nvPicPr>
-        <p:blipFill>
-          <a:blip r:embed="rId6"/>
-          <a:stretch>
-            <a:fillRect/>
-          </a:stretch>
-        </p:blipFill>
-        <p:spPr>
-          <a:xfrm>
-            <a:off x="6064301" y="3183941"/>
-            <a:ext cx="261518" cy="261518"/>
-          </a:xfrm>
-          <a:prstGeom prst="rect">
-            <a:avLst/>
-          </a:prstGeom>
-        </p:spPr>
-      </p:pic>
-      <p:sp>
-        <p:nvSpPr>
-          <p:cNvPr id="35" name="Text 27"/>
-          <p:cNvSpPr txBox="1"/>
-          <p:nvPr/>
-        </p:nvSpPr>
-        <p:spPr>
-          <a:xfrm>
-            <a:off x="5943600" y="3675888"/>
-            <a:ext cx="1290218" cy="365760"/>
-          </a:xfrm>
-          <a:prstGeom prst="rect">
-            <a:avLst/>
-          </a:prstGeom>
-          <a:noFill/>
-          <a:ln/>
-        </p:spPr>
-        <p:txBody>
-          <a:bodyPr wrap="square" lIns="0" tIns="0" rIns="0" bIns="0" rtlCol="0" anchor="ctr"/>
-          <a:lstStyle/>
-          <a:p>
-            <a:pPr indent="0" marL="0">
-              <a:buNone/>
-            </a:pPr>
-            <a:r>
-              <a:rPr lang="en-US" sz="1700" b="1" dirty="0">
-                <a:solidFill>
-                  <a:srgbClr val="FFFFFF"/>
-                </a:solidFill>
-                <a:latin typeface="Calibri" pitchFamily="34" charset="0"/>
-                <a:ea typeface="Calibri" pitchFamily="34" charset="-122"/>
-                <a:cs typeface="Calibri" pitchFamily="34" charset="-120"/>
-              </a:rPr>
-              <a:t>TikTok</a:t>
-            </a:r>
-            <a:endParaRPr lang="en-US" sz="1700" dirty="0"/>
-          </a:p>
-        </p:txBody>
-      </p:sp>
-      <p:sp>
-        <p:nvSpPr>
-          <p:cNvPr id="36" name="Shape 28"/>
-          <p:cNvSpPr/>
-          <p:nvPr/>
-        </p:nvSpPr>
-        <p:spPr>
-          <a:xfrm>
-            <a:off x="5943600" y="4096512"/>
-            <a:ext cx="960120" cy="274320"/>
-          </a:xfrm>
-          <a:prstGeom prst="roundRect">
-            <a:avLst>
-              <a:gd name="adj" fmla="val 50000"/>
-            </a:avLst>
-          </a:prstGeom>
-          <a:solidFill>
-            <a:srgbClr val="C8742B"/>
-          </a:solidFill>
-          <a:ln w="12700">
-            <a:solidFill>
-              <a:srgbClr val="C8742B"/>
-            </a:solidFill>
-            <a:prstDash val="solid"/>
-          </a:ln>
-        </p:spPr>
-      </p:sp>
-      <p:sp>
-        <p:nvSpPr>
-          <p:cNvPr id="37" name="Text 29"/>
-          <p:cNvSpPr txBox="1"/>
-          <p:nvPr/>
-        </p:nvSpPr>
-        <p:spPr>
-          <a:xfrm>
-            <a:off x="5943600" y="4096512"/>
-            <a:ext cx="960120" cy="274320"/>
-          </a:xfrm>
-          <a:prstGeom prst="rect">
-            <a:avLst/>
-          </a:prstGeom>
-          <a:noFill/>
-          <a:ln/>
-        </p:spPr>
-        <p:txBody>
-          <a:bodyPr wrap="square" lIns="0" tIns="0" rIns="0" bIns="0" rtlCol="0" anchor="ctr"/>
-          <a:lstStyle/>
-          <a:p>
-            <a:pPr algn="ctr" indent="0" marL="0">
-              <a:buNone/>
-            </a:pPr>
-            <a:r>
-              <a:rPr lang="en-US" sz="1050" b="1" dirty="0">
-                <a:solidFill>
-                  <a:srgbClr val="FFFFFF"/>
-                </a:solidFill>
-                <a:latin typeface="Calibri" pitchFamily="34" charset="0"/>
-                <a:ea typeface="Calibri" pitchFamily="34" charset="-122"/>
-                <a:cs typeface="Calibri" pitchFamily="34" charset="-120"/>
-              </a:rPr>
-              <a:t>Aktif</a:t>
-            </a:r>
-            <a:endParaRPr lang="en-US" sz="1050" dirty="0"/>
-          </a:p>
-        </p:txBody>
-      </p:sp>
-      <p:sp>
-        <p:nvSpPr>
-          <p:cNvPr id="38" name="Text 30"/>
-          <p:cNvSpPr txBox="1"/>
-          <p:nvPr/>
-        </p:nvSpPr>
-        <p:spPr>
-          <a:xfrm>
-            <a:off x="5943600" y="4462272"/>
-            <a:ext cx="1335938" cy="548640"/>
-          </a:xfrm>
-          <a:prstGeom prst="rect">
-            <a:avLst/>
-          </a:prstGeom>
-          <a:noFill/>
-          <a:ln/>
-        </p:spPr>
-        <p:txBody>
-          <a:bodyPr wrap="square" lIns="0" tIns="0" rIns="0" bIns="0" rtlCol="0" anchor="t"/>
-          <a:lstStyle/>
-          <a:p>
-            <a:pPr indent="0" marL="0">
-              <a:buNone/>
-            </a:pPr>
-            <a:r>
-              <a:rPr lang="en-US" sz="1200" dirty="0">
-                <a:solidFill>
-                  <a:srgbClr val="C3CEDD"/>
-                </a:solidFill>
-                <a:latin typeface="Calibri" pitchFamily="34" charset="0"/>
-                <a:ea typeface="Calibri" pitchFamily="34" charset="-122"/>
-                <a:cs typeface="Calibri" pitchFamily="34" charset="-120"/>
-              </a:rPr>
-              <a:t>Satu-satunya channel digital yang masih bawa jualan.</a:t>
-            </a:r>
-            <a:endParaRPr lang="en-US" sz="1200" dirty="0"/>
-          </a:p>
-        </p:txBody>
-      </p:sp>
-      <p:sp>
-        <p:nvSpPr>
-          <p:cNvPr id="39" name="Shape 31"/>
-          <p:cNvSpPr/>
-          <p:nvPr/>
-        </p:nvSpPr>
-        <p:spPr>
-          <a:xfrm>
-            <a:off x="7645298" y="2834640"/>
-            <a:ext cx="1747418" cy="2240280"/>
-          </a:xfrm>
-          <a:prstGeom prst="roundRect">
-            <a:avLst>
-              <a:gd name="adj" fmla="val 4186"/>
-            </a:avLst>
-          </a:prstGeom>
-          <a:solidFill>
-            <a:srgbClr val="17325A"/>
-          </a:solidFill>
-          <a:ln w="9525">
-            <a:solidFill>
-              <a:srgbClr val="23436F"/>
-            </a:solidFill>
-            <a:prstDash val="solid"/>
-          </a:ln>
-        </p:spPr>
-      </p:sp>
-      <p:sp>
-        <p:nvSpPr>
-          <p:cNvPr id="40" name="Shape 32"/>
-          <p:cNvSpPr/>
-          <p:nvPr/>
-        </p:nvSpPr>
-        <p:spPr>
-          <a:xfrm>
-            <a:off x="7873898" y="3063240"/>
-            <a:ext cx="502920" cy="502920"/>
-          </a:xfrm>
-          <a:prstGeom prst="ellipse">
-            <a:avLst>
-              <a:gd name="adj" fmla="val 22000"/>
-            </a:avLst>
-          </a:prstGeom>
-          <a:solidFill>
-            <a:srgbClr val="23436F"/>
-          </a:solidFill>
-          <a:ln w="12700">
-            <a:solidFill>
-              <a:srgbClr val="23436F"/>
-            </a:solidFill>
-            <a:prstDash val="solid"/>
-          </a:ln>
-        </p:spPr>
-      </p:sp>
-      <p:pic>
-        <p:nvPicPr>
-          <p:cNvPr id="41" name="Image 6" descr="preencoded.png">    </p:cNvPr>
-          <p:cNvPicPr>
-            <a:picLocks noChangeAspect="1"/>
-          </p:cNvPicPr>
-          <p:nvPr/>
-        </p:nvPicPr>
-        <p:blipFill>
-          <a:blip r:embed="rId7"/>
-          <a:stretch>
-            <a:fillRect/>
-          </a:stretch>
-        </p:blipFill>
-        <p:spPr>
-          <a:xfrm>
-            <a:off x="7994599" y="3183941"/>
-            <a:ext cx="261518" cy="261518"/>
-          </a:xfrm>
-          <a:prstGeom prst="rect">
-            <a:avLst/>
-          </a:prstGeom>
-        </p:spPr>
-      </p:pic>
-      <p:sp>
-        <p:nvSpPr>
-          <p:cNvPr id="42" name="Text 33"/>
-          <p:cNvSpPr txBox="1"/>
-          <p:nvPr/>
-        </p:nvSpPr>
-        <p:spPr>
-          <a:xfrm>
-            <a:off x="7873898" y="3675888"/>
-            <a:ext cx="1290218" cy="365760"/>
-          </a:xfrm>
-          <a:prstGeom prst="rect">
-            <a:avLst/>
-          </a:prstGeom>
-          <a:noFill/>
-          <a:ln/>
-        </p:spPr>
-        <p:txBody>
-          <a:bodyPr wrap="square" lIns="0" tIns="0" rIns="0" bIns="0" rtlCol="0" anchor="ctr"/>
-          <a:lstStyle/>
-          <a:p>
-            <a:pPr indent="0" marL="0">
-              <a:buNone/>
-            </a:pPr>
-            <a:r>
-              <a:rPr lang="en-US" sz="1700" b="1" dirty="0">
-                <a:solidFill>
-                  <a:srgbClr val="FFFFFF"/>
-                </a:solidFill>
-                <a:latin typeface="Calibri" pitchFamily="34" charset="0"/>
-                <a:ea typeface="Calibri" pitchFamily="34" charset="-122"/>
-                <a:cs typeface="Calibri" pitchFamily="34" charset="-120"/>
-              </a:rPr>
-              <a:t>Facebook</a:t>
-            </a:r>
-            <a:endParaRPr lang="en-US" sz="1700" dirty="0"/>
-          </a:p>
-        </p:txBody>
-      </p:sp>
-      <p:sp>
-        <p:nvSpPr>
-          <p:cNvPr id="43" name="Shape 34"/>
-          <p:cNvSpPr/>
-          <p:nvPr/>
-        </p:nvSpPr>
-        <p:spPr>
-          <a:xfrm>
-            <a:off x="7873898" y="4096512"/>
-            <a:ext cx="960120" cy="274320"/>
-          </a:xfrm>
-          <a:prstGeom prst="roundRect">
-            <a:avLst>
-              <a:gd name="adj" fmla="val 50000"/>
-            </a:avLst>
-          </a:prstGeom>
-          <a:solidFill>
-            <a:srgbClr val="23436F"/>
-          </a:solidFill>
-          <a:ln w="12700">
-            <a:solidFill>
-              <a:srgbClr val="23436F"/>
-            </a:solidFill>
-            <a:prstDash val="solid"/>
-          </a:ln>
-        </p:spPr>
-      </p:sp>
-      <p:sp>
-        <p:nvSpPr>
-          <p:cNvPr id="44" name="Text 35"/>
-          <p:cNvSpPr txBox="1"/>
-          <p:nvPr/>
-        </p:nvSpPr>
-        <p:spPr>
-          <a:xfrm>
-            <a:off x="7873898" y="4096512"/>
-            <a:ext cx="960120" cy="274320"/>
-          </a:xfrm>
-          <a:prstGeom prst="rect">
-            <a:avLst/>
-          </a:prstGeom>
-          <a:noFill/>
-          <a:ln/>
-        </p:spPr>
-        <p:txBody>
-          <a:bodyPr wrap="square" lIns="0" tIns="0" rIns="0" bIns="0" rtlCol="0" anchor="ctr"/>
-          <a:lstStyle/>
-          <a:p>
-            <a:pPr algn="ctr" indent="0" marL="0">
-              <a:buNone/>
-            </a:pPr>
-            <a:r>
-              <a:rPr lang="en-US" sz="1050" b="1" dirty="0">
-                <a:solidFill>
-                  <a:srgbClr val="FFFFFF"/>
-                </a:solidFill>
-                <a:latin typeface="Calibri" pitchFamily="34" charset="0"/>
-                <a:ea typeface="Calibri" pitchFamily="34" charset="-122"/>
-                <a:cs typeface="Calibri" pitchFamily="34" charset="-120"/>
-              </a:rPr>
-              <a:t>Menurun</a:t>
-            </a:r>
-            <a:endParaRPr lang="en-US" sz="1050" dirty="0"/>
-          </a:p>
-        </p:txBody>
-      </p:sp>
-      <p:sp>
-        <p:nvSpPr>
-          <p:cNvPr id="45" name="Text 36"/>
-          <p:cNvSpPr txBox="1"/>
-          <p:nvPr/>
-        </p:nvSpPr>
-        <p:spPr>
-          <a:xfrm>
-            <a:off x="7873898" y="4462272"/>
-            <a:ext cx="1335938" cy="548640"/>
-          </a:xfrm>
-          <a:prstGeom prst="rect">
-            <a:avLst/>
-          </a:prstGeom>
-          <a:noFill/>
-          <a:ln/>
-        </p:spPr>
-        <p:txBody>
-          <a:bodyPr wrap="square" lIns="0" tIns="0" rIns="0" bIns="0" rtlCol="0" anchor="t"/>
-          <a:lstStyle/>
-          <a:p>
-            <a:pPr indent="0" marL="0">
-              <a:buNone/>
-            </a:pPr>
-            <a:r>
-              <a:rPr lang="en-US" sz="1200" dirty="0">
-                <a:solidFill>
-                  <a:srgbClr val="C3CEDD"/>
-                </a:solidFill>
-                <a:latin typeface="Calibri" pitchFamily="34" charset="0"/>
-                <a:ea typeface="Calibri" pitchFamily="34" charset="-122"/>
-                <a:cs typeface="Calibri" pitchFamily="34" charset="-120"/>
-              </a:rPr>
-              <a:t>Jualan 9 → 0, Januari ke Ogos.</a:t>
-            </a:r>
-            <a:endParaRPr lang="en-US" sz="1200" dirty="0"/>
-          </a:p>
-        </p:txBody>
-      </p:sp>
-      <p:sp>
-        <p:nvSpPr>
-          <p:cNvPr id="46" name="Shape 37"/>
-          <p:cNvSpPr/>
-          <p:nvPr/>
-        </p:nvSpPr>
-        <p:spPr>
-          <a:xfrm>
-            <a:off x="9575597" y="2834640"/>
-            <a:ext cx="1747418" cy="2240280"/>
-          </a:xfrm>
-          <a:prstGeom prst="roundRect">
-            <a:avLst>
-              <a:gd name="adj" fmla="val 4186"/>
-            </a:avLst>
-          </a:prstGeom>
-          <a:solidFill>
-            <a:srgbClr val="17325A"/>
-          </a:solidFill>
-          <a:ln w="9525">
-            <a:solidFill>
-              <a:srgbClr val="23436F"/>
-            </a:solidFill>
-            <a:prstDash val="solid"/>
-          </a:ln>
-        </p:spPr>
-      </p:sp>
-      <p:sp>
-        <p:nvSpPr>
-          <p:cNvPr id="47" name="Shape 38"/>
-          <p:cNvSpPr/>
-          <p:nvPr/>
-        </p:nvSpPr>
-        <p:spPr>
-          <a:xfrm>
-            <a:off x="9804197" y="3063240"/>
-            <a:ext cx="502920" cy="502920"/>
-          </a:xfrm>
-          <a:prstGeom prst="ellipse">
-            <a:avLst>
-              <a:gd name="adj" fmla="val 22000"/>
-            </a:avLst>
-          </a:prstGeom>
-          <a:solidFill>
-            <a:srgbClr val="23436F"/>
-          </a:solidFill>
-          <a:ln w="12700">
-            <a:solidFill>
-              <a:srgbClr val="23436F"/>
-            </a:solidFill>
-            <a:prstDash val="solid"/>
-          </a:ln>
-        </p:spPr>
-      </p:sp>
-      <p:pic>
-        <p:nvPicPr>
-          <p:cNvPr id="48" name="Image 7" descr="preencoded.png">    </p:cNvPr>
+          <p:cNvPr id="50" name="Image 7" descr="preencoded.png">    </p:cNvPr>
           <p:cNvPicPr>
             <a:picLocks noChangeAspect="1"/>
           </p:cNvPicPr>
@@ -27157,8 +27227,8 @@
         </p:blipFill>
         <p:spPr>
           <a:xfrm>
-            <a:off x="9924898" y="3183941"/>
-            <a:ext cx="261518" cy="261518"/>
+            <a:off x="7840797" y="3844869"/>
+            <a:ext cx="247254" cy="247254"/>
           </a:xfrm>
           <a:prstGeom prst="rect">
             <a:avLst/>
@@ -27167,14 +27237,14 @@
       </p:pic>
       <p:sp>
         <p:nvSpPr>
-          <p:cNvPr id="49" name="Text 39"/>
-          <p:cNvSpPr txBox="1"/>
-          <p:nvPr/>
-        </p:nvSpPr>
-        <p:spPr>
-          <a:xfrm>
-            <a:off x="9804197" y="3675888"/>
-            <a:ext cx="1290218" cy="365760"/>
+          <p:cNvPr id="51" name="Text 41"/>
+          <p:cNvSpPr txBox="1"/>
+          <p:nvPr/>
+        </p:nvSpPr>
+        <p:spPr>
+          <a:xfrm>
+            <a:off x="8366760" y="3657600"/>
+            <a:ext cx="1463040" cy="310896"/>
           </a:xfrm>
           <a:prstGeom prst="rect">
             <a:avLst/>
@@ -27190,42 +27260,42 @@
               <a:buNone/>
             </a:pPr>
             <a:r>
-              <a:rPr lang="en-US" sz="1700" b="1" dirty="0">
-                <a:solidFill>
-                  <a:srgbClr val="FFFFFF"/>
-                </a:solidFill>
-                <a:latin typeface="Calibri" pitchFamily="34" charset="0"/>
-                <a:ea typeface="Calibri" pitchFamily="34" charset="-122"/>
-                <a:cs typeface="Calibri" pitchFamily="34" charset="-120"/>
-              </a:rPr>
-              <a:t>Threads</a:t>
-            </a:r>
-            <a:endParaRPr lang="en-US" sz="1700" dirty="0"/>
-          </a:p>
-        </p:txBody>
-      </p:sp>
-      <p:sp>
-        <p:nvSpPr>
-          <p:cNvPr id="50" name="Shape 40"/>
+              <a:rPr lang="en-US" sz="1500" b="1" dirty="0">
+                <a:solidFill>
+                  <a:srgbClr val="0B1F3A"/>
+                </a:solidFill>
+                <a:latin typeface="Calibri" pitchFamily="34" charset="0"/>
+                <a:ea typeface="Calibri" pitchFamily="34" charset="-122"/>
+                <a:cs typeface="Calibri" pitchFamily="34" charset="-120"/>
+              </a:rPr>
+              <a:t>Facebook</a:t>
+            </a:r>
+            <a:endParaRPr lang="en-US" sz="1500" dirty="0"/>
+          </a:p>
+        </p:txBody>
+      </p:sp>
+      <p:sp>
+        <p:nvSpPr>
+          <p:cNvPr id="52" name="Shape 42"/>
           <p:cNvSpPr/>
           <p:nvPr/>
         </p:nvSpPr>
         <p:spPr>
           <a:xfrm>
-            <a:off x="9804197" y="4096512"/>
-            <a:ext cx="960120" cy="274320"/>
+            <a:off x="10362895" y="3694176"/>
+            <a:ext cx="960120" cy="246888"/>
           </a:xfrm>
           <a:prstGeom prst="roundRect">
             <a:avLst>
-              <a:gd name="adj" fmla="val 50000"/>
+              <a:gd name="adj" fmla="val 48148"/>
             </a:avLst>
           </a:prstGeom>
           <a:solidFill>
-            <a:srgbClr val="23436F"/>
+            <a:srgbClr val="5B6B80"/>
           </a:solidFill>
           <a:ln w="12700">
             <a:solidFill>
-              <a:srgbClr val="23436F"/>
+              <a:srgbClr val="5B6B80"/>
             </a:solidFill>
             <a:prstDash val="solid"/>
           </a:ln>
@@ -27233,14 +27303,14 @@
       </p:sp>
       <p:sp>
         <p:nvSpPr>
-          <p:cNvPr id="51" name="Text 41"/>
-          <p:cNvSpPr txBox="1"/>
-          <p:nvPr/>
-        </p:nvSpPr>
-        <p:spPr>
-          <a:xfrm>
-            <a:off x="9804197" y="4096512"/>
-            <a:ext cx="960120" cy="274320"/>
+          <p:cNvPr id="53" name="Text 43"/>
+          <p:cNvSpPr txBox="1"/>
+          <p:nvPr/>
+        </p:nvSpPr>
+        <p:spPr>
+          <a:xfrm>
+            <a:off x="10362895" y="3694176"/>
+            <a:ext cx="960120" cy="246888"/>
           </a:xfrm>
           <a:prstGeom prst="rect">
             <a:avLst/>
@@ -27256,7 +27326,7 @@
               <a:buNone/>
             </a:pPr>
             <a:r>
-              <a:rPr lang="en-US" sz="1050" b="1" dirty="0">
+              <a:rPr lang="en-US" sz="1000" b="1" dirty="0">
                 <a:solidFill>
                   <a:srgbClr val="FFFFFF"/>
                 </a:solidFill>
@@ -27264,31 +27334,249 @@
                 <a:ea typeface="Calibri" pitchFamily="34" charset="-122"/>
                 <a:cs typeface="Calibri" pitchFamily="34" charset="-120"/>
               </a:rPr>
+              <a:t>Menurun</a:t>
+            </a:r>
+            <a:endParaRPr lang="en-US" sz="1000" dirty="0"/>
+          </a:p>
+        </p:txBody>
+      </p:sp>
+      <p:sp>
+        <p:nvSpPr>
+          <p:cNvPr id="54" name="Text 44"/>
+          <p:cNvSpPr txBox="1"/>
+          <p:nvPr/>
+        </p:nvSpPr>
+        <p:spPr>
+          <a:xfrm>
+            <a:off x="8366760" y="3986784"/>
+            <a:ext cx="2956255" cy="310896"/>
+          </a:xfrm>
+          <a:prstGeom prst="rect">
+            <a:avLst/>
+          </a:prstGeom>
+          <a:noFill/>
+          <a:ln/>
+        </p:spPr>
+        <p:txBody>
+          <a:bodyPr wrap="square" lIns="0" tIns="0" rIns="0" bIns="0" rtlCol="0" anchor="ctr"/>
+          <a:lstStyle/>
+          <a:p>
+            <a:pPr indent="0" marL="0">
+              <a:buNone/>
+            </a:pPr>
+            <a:r>
+              <a:rPr lang="en-US" sz="1200" dirty="0">
+                <a:solidFill>
+                  <a:srgbClr val="5B6B80"/>
+                </a:solidFill>
+                <a:latin typeface="Calibri" pitchFamily="34" charset="0"/>
+                <a:ea typeface="Calibri" pitchFamily="34" charset="-122"/>
+                <a:cs typeface="Calibri" pitchFamily="34" charset="-120"/>
+              </a:rPr>
+              <a:t>Jualan 9 → 0, Januari ke Ogos.</a:t>
+            </a:r>
+            <a:endParaRPr lang="en-US" sz="1200" dirty="0"/>
+          </a:p>
+        </p:txBody>
+      </p:sp>
+      <p:sp>
+        <p:nvSpPr>
+          <p:cNvPr id="55" name="Shape 45"/>
+          <p:cNvSpPr/>
+          <p:nvPr/>
+        </p:nvSpPr>
+        <p:spPr>
+          <a:xfrm>
+            <a:off x="7726680" y="4389120"/>
+            <a:ext cx="3596335" cy="0"/>
+          </a:xfrm>
+          <a:prstGeom prst="line">
+            <a:avLst/>
+          </a:prstGeom>
+          <a:noFill/>
+          <a:ln w="9525">
+            <a:solidFill>
+              <a:srgbClr val="D8E0EA"/>
+            </a:solidFill>
+            <a:prstDash val="solid"/>
+          </a:ln>
+        </p:spPr>
+      </p:sp>
+      <p:sp>
+        <p:nvSpPr>
+          <p:cNvPr id="56" name="Shape 46"/>
+          <p:cNvSpPr/>
+          <p:nvPr/>
+        </p:nvSpPr>
+        <p:spPr>
+          <a:xfrm>
+            <a:off x="7726680" y="4553712"/>
+            <a:ext cx="475488" cy="475488"/>
+          </a:xfrm>
+          <a:prstGeom prst="ellipse">
+            <a:avLst>
+              <a:gd name="adj" fmla="val 22000"/>
+            </a:avLst>
+          </a:prstGeom>
+          <a:solidFill>
+            <a:srgbClr val="0B1F3A"/>
+          </a:solidFill>
+          <a:ln w="12700">
+            <a:solidFill>
+              <a:srgbClr val="0B1F3A"/>
+            </a:solidFill>
+            <a:prstDash val="solid"/>
+          </a:ln>
+        </p:spPr>
+      </p:sp>
+      <p:pic>
+        <p:nvPicPr>
+          <p:cNvPr id="57" name="Image 8" descr="preencoded.png">    </p:cNvPr>
+          <p:cNvPicPr>
+            <a:picLocks noChangeAspect="1"/>
+          </p:cNvPicPr>
+          <p:nvPr/>
+        </p:nvPicPr>
+        <p:blipFill>
+          <a:blip r:embed="rId9"/>
+          <a:stretch>
+            <a:fillRect/>
+          </a:stretch>
+        </p:blipFill>
+        <p:spPr>
+          <a:xfrm>
+            <a:off x="7840797" y="4667829"/>
+            <a:ext cx="247254" cy="247254"/>
+          </a:xfrm>
+          <a:prstGeom prst="rect">
+            <a:avLst/>
+          </a:prstGeom>
+        </p:spPr>
+      </p:pic>
+      <p:sp>
+        <p:nvSpPr>
+          <p:cNvPr id="58" name="Text 47"/>
+          <p:cNvSpPr txBox="1"/>
+          <p:nvPr/>
+        </p:nvSpPr>
+        <p:spPr>
+          <a:xfrm>
+            <a:off x="8366760" y="4480560"/>
+            <a:ext cx="1463040" cy="310896"/>
+          </a:xfrm>
+          <a:prstGeom prst="rect">
+            <a:avLst/>
+          </a:prstGeom>
+          <a:noFill/>
+          <a:ln/>
+        </p:spPr>
+        <p:txBody>
+          <a:bodyPr wrap="square" lIns="0" tIns="0" rIns="0" bIns="0" rtlCol="0" anchor="ctr"/>
+          <a:lstStyle/>
+          <a:p>
+            <a:pPr indent="0" marL="0">
+              <a:buNone/>
+            </a:pPr>
+            <a:r>
+              <a:rPr lang="en-US" sz="1500" b="1" dirty="0">
+                <a:solidFill>
+                  <a:srgbClr val="0B1F3A"/>
+                </a:solidFill>
+                <a:latin typeface="Calibri" pitchFamily="34" charset="0"/>
+                <a:ea typeface="Calibri" pitchFamily="34" charset="-122"/>
+                <a:cs typeface="Calibri" pitchFamily="34" charset="-120"/>
+              </a:rPr>
+              <a:t>Threads</a:t>
+            </a:r>
+            <a:endParaRPr lang="en-US" sz="1500" dirty="0"/>
+          </a:p>
+        </p:txBody>
+      </p:sp>
+      <p:sp>
+        <p:nvSpPr>
+          <p:cNvPr id="59" name="Shape 48"/>
+          <p:cNvSpPr/>
+          <p:nvPr/>
+        </p:nvSpPr>
+        <p:spPr>
+          <a:xfrm>
+            <a:off x="10362895" y="4517136"/>
+            <a:ext cx="960120" cy="246888"/>
+          </a:xfrm>
+          <a:prstGeom prst="roundRect">
+            <a:avLst>
+              <a:gd name="adj" fmla="val 48148"/>
+            </a:avLst>
+          </a:prstGeom>
+          <a:solidFill>
+            <a:srgbClr val="0B1F3A"/>
+          </a:solidFill>
+          <a:ln w="12700">
+            <a:solidFill>
+              <a:srgbClr val="0B1F3A"/>
+            </a:solidFill>
+            <a:prstDash val="solid"/>
+          </a:ln>
+        </p:spPr>
+      </p:sp>
+      <p:sp>
+        <p:nvSpPr>
+          <p:cNvPr id="60" name="Text 49"/>
+          <p:cNvSpPr txBox="1"/>
+          <p:nvPr/>
+        </p:nvSpPr>
+        <p:spPr>
+          <a:xfrm>
+            <a:off x="10362895" y="4517136"/>
+            <a:ext cx="960120" cy="246888"/>
+          </a:xfrm>
+          <a:prstGeom prst="rect">
+            <a:avLst/>
+          </a:prstGeom>
+          <a:noFill/>
+          <a:ln/>
+        </p:spPr>
+        <p:txBody>
+          <a:bodyPr wrap="square" lIns="0" tIns="0" rIns="0" bIns="0" rtlCol="0" anchor="ctr"/>
+          <a:lstStyle/>
+          <a:p>
+            <a:pPr algn="ctr" indent="0" marL="0">
+              <a:buNone/>
+            </a:pPr>
+            <a:r>
+              <a:rPr lang="en-US" sz="1000" b="1" dirty="0">
+                <a:solidFill>
+                  <a:srgbClr val="FFFFFF"/>
+                </a:solidFill>
+                <a:latin typeface="Calibri" pitchFamily="34" charset="0"/>
+                <a:ea typeface="Calibri" pitchFamily="34" charset="-122"/>
+                <a:cs typeface="Calibri" pitchFamily="34" charset="-120"/>
+              </a:rPr>
               <a:t>Terkini</a:t>
             </a:r>
-            <a:endParaRPr lang="en-US" sz="1050" dirty="0"/>
-          </a:p>
-        </p:txBody>
-      </p:sp>
-      <p:sp>
-        <p:nvSpPr>
-          <p:cNvPr id="52" name="Text 42"/>
-          <p:cNvSpPr txBox="1"/>
-          <p:nvPr/>
-        </p:nvSpPr>
-        <p:spPr>
-          <a:xfrm>
-            <a:off x="9804197" y="4462272"/>
-            <a:ext cx="1335938" cy="548640"/>
-          </a:xfrm>
-          <a:prstGeom prst="rect">
-            <a:avLst/>
-          </a:prstGeom>
-          <a:noFill/>
-          <a:ln/>
-        </p:spPr>
-        <p:txBody>
-          <a:bodyPr wrap="square" lIns="0" tIns="0" rIns="0" bIns="0" rtlCol="0" anchor="t"/>
+            <a:endParaRPr lang="en-US" sz="1000" dirty="0"/>
+          </a:p>
+        </p:txBody>
+      </p:sp>
+      <p:sp>
+        <p:nvSpPr>
+          <p:cNvPr id="61" name="Text 50"/>
+          <p:cNvSpPr txBox="1"/>
+          <p:nvPr/>
+        </p:nvSpPr>
+        <p:spPr>
+          <a:xfrm>
+            <a:off x="8366760" y="4809744"/>
+            <a:ext cx="2956255" cy="310896"/>
+          </a:xfrm>
+          <a:prstGeom prst="rect">
+            <a:avLst/>
+          </a:prstGeom>
+          <a:noFill/>
+          <a:ln/>
+        </p:spPr>
+        <p:txBody>
+          <a:bodyPr wrap="square" lIns="0" tIns="0" rIns="0" bIns="0" rtlCol="0" anchor="ctr"/>
           <a:lstStyle/>
           <a:p>
             <a:pPr indent="0" marL="0">
@@ -27297,7 +27585,7 @@
             <a:r>
               <a:rPr lang="en-US" sz="1200" dirty="0">
                 <a:solidFill>
-                  <a:srgbClr val="C3CEDD"/>
+                  <a:srgbClr val="5B6B80"/>
                 </a:solidFill>
                 <a:latin typeface="Calibri" pitchFamily="34" charset="0"/>
                 <a:ea typeface="Calibri" pitchFamily="34" charset="-122"/>
@@ -27311,7 +27599,7 @@
       </p:sp>
       <p:sp>
         <p:nvSpPr>
-          <p:cNvPr id="53" name="Shape 43"/>
+          <p:cNvPr id="62" name="Shape 51"/>
           <p:cNvSpPr/>
           <p:nvPr/>
         </p:nvSpPr>
@@ -27338,14 +27626,14 @@
       </p:sp>
       <p:pic>
         <p:nvPicPr>
-          <p:cNvPr id="54" name="Image 8" descr="preencoded.png">    </p:cNvPr>
+          <p:cNvPr id="63" name="Image 9" descr="preencoded.png">    </p:cNvPr>
           <p:cNvPicPr>
             <a:picLocks noChangeAspect="1"/>
           </p:cNvPicPr>
           <p:nvPr/>
         </p:nvPicPr>
         <p:blipFill>
-          <a:blip r:embed="rId9"/>
+          <a:blip r:embed="rId10"/>
           <a:stretch>
             <a:fillRect/>
           </a:stretch>
@@ -27362,7 +27650,7 @@
       </p:pic>
       <p:sp>
         <p:nvSpPr>
-          <p:cNvPr id="55" name="Text 44"/>
+          <p:cNvPr id="64" name="Text 52"/>
           <p:cNvSpPr txBox="1"/>
           <p:nvPr/>
         </p:nvSpPr>

</xml_diff>